<commit_message>
[docs] update SOP with usage scenarios, model config, and batch hook commands
- Add chapter 8 (使用情境) with 4 practical scenarios
- Add chapter 9 (更換/設定 LLM Model) with remote server setup
- Update chapter 5 (hooks) to reflect auto-install and batch operations
- Update TOC and renumber chapters 10-12
- Regenerate PPT (34 → 36 slides)

Co-Authored-By: Claude Opus 4.6 <noreply@anthropic.com>
</commit_message>
<xml_diff>
--- a/docs/SOP-cross-platform.pptx
+++ b/docs/SOP-cross-platform.pptx
@@ -39,6 +39,10 @@
     <p:sldId id="287" r:id="rId38"/>
     <p:sldId id="288" r:id="rId39"/>
     <p:sldId id="289" r:id="rId40"/>
+    <p:sldId id="290" r:id="rId41"/>
+    <p:sldId id="291" r:id="rId42"/>
+    <p:sldId id="292" r:id="rId43"/>
+    <p:sldId id="293" r:id="rId44"/>
   </p:sldIdLst>
   <p:sldSz cx="12191695" cy="6858000" type="screen4x3"/>
   <p:notesSz cx="6858000" cy="9144000"/>
@@ -4328,7 +4332,7 @@
               </a:defRPr>
             </a:pPr>
             <a:r>
-              <a:t>方式一：Template Hooks（推薦，適合團隊）</a:t>
+              <a:t>方式一：Template Hooks（推薦）</a:t>
             </a:r>
           </a:p>
           <a:p>
@@ -4346,7 +4350,7 @@
               </a:defRPr>
             </a:pPr>
             <a:r>
-              <a:t>$ ai-review hook install --template</a:t>
+              <a:t>$ ai-review hook install --template    # 一次性全域設定</a:t>
             </a:r>
           </a:p>
           <a:p>
@@ -4364,7 +4368,7 @@
               </a:defRPr>
             </a:pPr>
             <a:r>
-              <a:t>$ cd /path/to/repo &amp;&amp; git init      # 既有 repo 需重新初始化</a:t>
+              <a:t>$ cd /path/to/repo</a:t>
             </a:r>
           </a:p>
           <a:p>
@@ -4382,7 +4386,7 @@
               </a:defRPr>
             </a:pPr>
             <a:r>
-              <a:t>$ ai-review hook enable              # 啟用（per-repo opt-in）</a:t>
+              <a:t>$ ai-review hook enable                # 自動設定 + 安裝 hooks</a:t>
             </a:r>
           </a:p>
           <a:p>
@@ -4415,7 +4419,7 @@
               </a:defRPr>
             </a:pPr>
             <a:r>
-              <a:t>方式二：Global Hooks（所有 repo 共用）</a:t>
+              <a:t>批量管理多個 Repo</a:t>
             </a:r>
           </a:p>
           <a:p>
@@ -4433,7 +4437,7 @@
               </a:defRPr>
             </a:pPr>
             <a:r>
-              <a:t>$ ai-review hook install --global</a:t>
+              <a:t>$ ai-review hook enable --all /workspace --list    # 預覽狀態</a:t>
             </a:r>
           </a:p>
           <a:p>
@@ -4451,17 +4455,53 @@
               </a:defRPr>
             </a:pPr>
             <a:r>
-              <a:t>$ cd /path/to/repo &amp;&amp; touch .ai-review   # marker 檔案</a:t>
-            </a:r>
-          </a:p>
-          <a:p>
-            <a:pPr>
+              <a:t>$ ai-review hook enable --all /workspace           # 全部啟用</a:t>
+            </a:r>
+          </a:p>
+          <a:p>
+            <a:pPr lvl="1">
               <a:spcBef>
                 <a:spcPts val="600"/>
               </a:spcBef>
               <a:spcAft>
                 <a:spcPts val="200"/>
               </a:spcAft>
+              <a:defRPr sz="1400" b="0">
+                <a:solidFill>
+                  <a:srgbClr val="FAB387"/>
+                </a:solidFill>
+              </a:defRPr>
+            </a:pPr>
+            <a:r>
+              <a:t>$ ai-review hook enable --path /repo1 --path /repo2</a:t>
+            </a:r>
+          </a:p>
+          <a:p>
+            <a:pPr lvl="1">
+              <a:spcBef>
+                <a:spcPts val="600"/>
+              </a:spcBef>
+              <a:spcAft>
+                <a:spcPts val="200"/>
+              </a:spcAft>
+              <a:defRPr sz="1400" b="0">
+                <a:solidFill>
+                  <a:srgbClr val="FAB387"/>
+                </a:solidFill>
+              </a:defRPr>
+            </a:pPr>
+            <a:r>
+              <a:t>$ ai-review hook disable --path /repo1             # 停用特定</a:t>
+            </a:r>
+          </a:p>
+          <a:p>
+            <a:pPr>
+              <a:spcBef>
+                <a:spcPts val="600"/>
+              </a:spcBef>
+              <a:spcAft>
+                <a:spcPts val="200"/>
+              </a:spcAft>
               <a:defRPr sz="800" b="0">
                 <a:solidFill>
                   <a:srgbClr val="CDD6F4"/>
@@ -4477,101 +4517,49 @@
               <a:spcAft>
                 <a:spcPts val="200"/>
               </a:spcAft>
-              <a:defRPr sz="1800" b="1">
-                <a:solidFill>
-                  <a:srgbClr val="74C7EC"/>
-                </a:solidFill>
-              </a:defRPr>
-            </a:pPr>
-            <a:r>
-              <a:t>方式三：單一 Repo Hooks</a:t>
-            </a:r>
-          </a:p>
-          <a:p>
-            <a:pPr lvl="1">
-              <a:spcBef>
-                <a:spcPts val="600"/>
-              </a:spcBef>
-              <a:spcAft>
-                <a:spcPts val="200"/>
-              </a:spcAft>
-              <a:defRPr sz="1400" b="0">
-                <a:solidFill>
-                  <a:srgbClr val="74C7EC"/>
-                </a:solidFill>
-              </a:defRPr>
-            </a:pPr>
-            <a:r>
-              <a:t>$ ai-review hook install prepare-commit-msg</a:t>
-            </a:r>
-          </a:p>
-          <a:p>
-            <a:pPr lvl="1">
-              <a:spcBef>
-                <a:spcPts val="600"/>
-              </a:spcBef>
-              <a:spcAft>
-                <a:spcPts val="200"/>
-              </a:spcAft>
-              <a:defRPr sz="1400" b="0">
-                <a:solidFill>
-                  <a:srgbClr val="74C7EC"/>
-                </a:solidFill>
-              </a:defRPr>
-            </a:pPr>
-            <a:r>
-              <a:t>$ ai-review hook install commit-msg</a:t>
-            </a:r>
-          </a:p>
-          <a:p>
-            <a:pPr lvl="1">
-              <a:spcBef>
-                <a:spcPts val="600"/>
-              </a:spcBef>
-              <a:spcAft>
-                <a:spcPts val="200"/>
-              </a:spcAft>
-              <a:defRPr sz="1400" b="0">
-                <a:solidFill>
-                  <a:srgbClr val="74C7EC"/>
-                </a:solidFill>
-              </a:defRPr>
-            </a:pPr>
-            <a:r>
-              <a:t>$ touch .ai-review</a:t>
-            </a:r>
-          </a:p>
-          <a:p>
-            <a:pPr>
-              <a:spcBef>
-                <a:spcPts val="600"/>
-              </a:spcBef>
-              <a:spcAft>
-                <a:spcPts val="200"/>
-              </a:spcAft>
-              <a:defRPr sz="800" b="0">
+              <a:defRPr sz="1600" b="1">
                 <a:solidFill>
                   <a:srgbClr val="CDD6F4"/>
                 </a:solidFill>
               </a:defRPr>
             </a:pPr>
-          </a:p>
-          <a:p>
-            <a:pPr>
-              <a:spcBef>
-                <a:spcPts val="600"/>
-              </a:spcBef>
-              <a:spcAft>
-                <a:spcPts val="200"/>
-              </a:spcAft>
-              <a:defRPr sz="1600" b="1">
-                <a:solidFill>
-                  <a:srgbClr val="CDD6F4"/>
-                </a:solidFill>
-              </a:defRPr>
-            </a:pPr>
             <a:r>
               <a:t>確認狀態：ai-review hook status</a:t>
+            </a:r>
+          </a:p>
+        </p:txBody>
+      </p:sp>
+      <p:sp>
+        <p:nvSpPr>
+          <p:cNvPr id="5" name="TextBox 4"/>
+          <p:cNvSpPr txBox="1"/>
+          <p:nvPr/>
+        </p:nvSpPr>
+        <p:spPr>
+          <a:xfrm>
+            <a:off x="457200" y="6217920"/>
+            <a:ext cx="10972800" cy="457200"/>
+          </a:xfrm>
+          <a:prstGeom prst="rect">
+            <a:avLst/>
+          </a:prstGeom>
+          <a:noFill/>
+        </p:spPr>
+        <p:txBody>
+          <a:bodyPr wrap="square">
+            <a:spAutoFit/>
+          </a:bodyPr>
+          <a:lstStyle/>
+          <a:p>
+            <a:pPr algn="l">
+              <a:defRPr sz="1200" b="0">
+                <a:solidFill>
+                  <a:srgbClr val="6C7086"/>
+                </a:solidFill>
+              </a:defRPr>
+            </a:pPr>
+            <a:r>
+              <a:t>hook enable 會同時設定 git config + 複製 hook 腳本到 .git/hooks/</a:t>
             </a:r>
           </a:p>
         </p:txBody>
@@ -6373,7 +6361,7 @@
               </a:defRPr>
             </a:pPr>
             <a:r>
-              <a:t>8.  常用指令速查表</a:t>
+              <a:t>8.  使用情境</a:t>
             </a:r>
           </a:p>
           <a:p>
@@ -6391,7 +6379,7 @@
               </a:defRPr>
             </a:pPr>
             <a:r>
-              <a:t>9.  疑難排解</a:t>
+              <a:t>9.  更換/設定 LLM Model</a:t>
             </a:r>
           </a:p>
           <a:p>
@@ -6409,7 +6397,43 @@
               </a:defRPr>
             </a:pPr>
             <a:r>
-              <a:t>10. 完整移除</a:t>
+              <a:t>10. 常用指令速查表</a:t>
+            </a:r>
+          </a:p>
+          <a:p>
+            <a:pPr>
+              <a:spcBef>
+                <a:spcPts val="600"/>
+              </a:spcBef>
+              <a:spcAft>
+                <a:spcPts val="200"/>
+              </a:spcAft>
+              <a:defRPr sz="2000" b="1">
+                <a:solidFill>
+                  <a:srgbClr val="89B4FA"/>
+                </a:solidFill>
+              </a:defRPr>
+            </a:pPr>
+            <a:r>
+              <a:t>11. 疑難排解</a:t>
+            </a:r>
+          </a:p>
+          <a:p>
+            <a:pPr>
+              <a:spcBef>
+                <a:spcPts val="600"/>
+              </a:spcBef>
+              <a:spcAft>
+                <a:spcPts val="200"/>
+              </a:spcAft>
+              <a:defRPr sz="2000" b="1">
+                <a:solidFill>
+                  <a:srgbClr val="89B4FA"/>
+                </a:solidFill>
+              </a:defRPr>
+            </a:pPr>
+            <a:r>
+              <a:t>12. 完整移除</a:t>
             </a:r>
           </a:p>
         </p:txBody>
@@ -6522,7 +6546,7 @@
               </a:defRPr>
             </a:pPr>
             <a:r>
-              <a:t>常用指令速查表</a:t>
+              <a:t>使用情境</a:t>
             </a:r>
           </a:p>
         </p:txBody>
@@ -6555,119 +6579,6 @@
       <p:grpSpPr/>
       <p:sp>
         <p:nvSpPr>
-          <p:cNvPr id="2" name="Oval 1"/>
-          <p:cNvSpPr/>
-          <p:nvPr/>
-        </p:nvSpPr>
-        <p:spPr>
-          <a:xfrm>
-            <a:off x="5394960" y="1828800"/>
-            <a:ext cx="1371600" cy="1371600"/>
-          </a:xfrm>
-          <a:prstGeom prst="ellipse">
-            <a:avLst/>
-          </a:prstGeom>
-          <a:solidFill>
-            <a:srgbClr val="89B4FA"/>
-          </a:solidFill>
-          <a:ln>
-            <a:noFill/>
-          </a:ln>
-        </p:spPr>
-        <p:style>
-          <a:lnRef idx="1">
-            <a:schemeClr val="accent1"/>
-          </a:lnRef>
-          <a:fillRef idx="3">
-            <a:schemeClr val="accent1"/>
-          </a:fillRef>
-          <a:effectRef idx="2">
-            <a:schemeClr val="accent1"/>
-          </a:effectRef>
-          <a:fontRef idx="minor">
-            <a:schemeClr val="lt1"/>
-          </a:fontRef>
-        </p:style>
-        <p:txBody>
-          <a:bodyPr rtlCol="0" anchor="ctr" wrap="square"/>
-          <a:lstStyle/>
-          <a:p>
-            <a:pPr algn="ctr">
-              <a:defRPr sz="4000" b="1">
-                <a:solidFill>
-                  <a:srgbClr val="1E1E2E"/>
-                </a:solidFill>
-              </a:defRPr>
-            </a:pPr>
-            <a:r>
-              <a:t>8</a:t>
-            </a:r>
-          </a:p>
-        </p:txBody>
-      </p:sp>
-      <p:sp>
-        <p:nvSpPr>
-          <p:cNvPr id="3" name="TextBox 2"/>
-          <p:cNvSpPr txBox="1"/>
-          <p:nvPr/>
-        </p:nvSpPr>
-        <p:spPr>
-          <a:xfrm>
-            <a:off x="914400" y="3474720"/>
-            <a:ext cx="10332720" cy="1097280"/>
-          </a:xfrm>
-          <a:prstGeom prst="rect">
-            <a:avLst/>
-          </a:prstGeom>
-          <a:noFill/>
-        </p:spPr>
-        <p:txBody>
-          <a:bodyPr wrap="square">
-            <a:spAutoFit/>
-          </a:bodyPr>
-          <a:lstStyle/>
-          <a:p>
-            <a:pPr algn="ctr">
-              <a:defRPr sz="3600" b="1">
-                <a:solidFill>
-                  <a:srgbClr val="CDD6F4"/>
-                </a:solidFill>
-              </a:defRPr>
-            </a:pPr>
-            <a:r>
-              <a:t>更換/設定 LLM Model</a:t>
-            </a:r>
-          </a:p>
-        </p:txBody>
-      </p:sp>
-    </p:spTree>
-  </p:cSld>
-  <p:clrMapOvr>
-    <a:masterClrMapping/>
-  </p:clrMapOvr>
-</p:sld>
-</file>
-
-<file path=ppt/slides/slide22.xml><?xml version="1.0" encoding="utf-8"?>
-<p:sld xmlns:a="http://schemas.openxmlformats.org/drawingml/2006/main" xmlns:p="http://schemas.openxmlformats.org/presentationml/2006/main" xmlns:r="http://schemas.openxmlformats.org/officeDocument/2006/relationships">
-  <p:cSld>
-    <p:bg>
-      <p:bgPr>
-        <a:solidFill>
-          <a:srgbClr val="1E1E2E"/>
-        </a:solidFill>
-        <a:effectLst/>
-      </p:bgPr>
-    </p:bg>
-    <p:spTree>
-      <p:nvGrpSpPr>
-        <p:cNvPr id="1" name=""/>
-        <p:cNvGrpSpPr/>
-        <p:nvPr/>
-      </p:nvGrpSpPr>
-      <p:grpSpPr/>
-      <p:sp>
-        <p:nvSpPr>
           <p:cNvPr id="2" name="TextBox 1"/>
           <p:cNvSpPr txBox="1"/>
           <p:nvPr/>
@@ -6696,7 +6607,7 @@
               </a:defRPr>
             </a:pPr>
             <a:r>
-              <a:t>8. 切換 Model（全平台通用）</a:t>
+              <a:t>8. 情境一：個人開發者</a:t>
             </a:r>
           </a:p>
         </p:txBody>
@@ -6776,7 +6687,7 @@
               </a:defRPr>
             </a:pPr>
             <a:r>
-              <a:t>下載新模型</a:t>
+              <a:t>一次性設定</a:t>
             </a:r>
           </a:p>
           <a:p>
@@ -6794,7 +6705,7 @@
               </a:defRPr>
             </a:pPr>
             <a:r>
-              <a:t>$ ollama pull llama3.2</a:t>
+              <a:t>$ pip install .</a:t>
             </a:r>
           </a:p>
           <a:p>
@@ -6812,7 +6723,7 @@
               </a:defRPr>
             </a:pPr>
             <a:r>
-              <a:t>$ ollama pull llama3.1</a:t>
+              <a:t>$ ai-review config set provider default ollama</a:t>
             </a:r>
           </a:p>
           <a:p>
@@ -6830,18 +6741,36 @@
               </a:defRPr>
             </a:pPr>
             <a:r>
-              <a:t>$ ollama list                              # 查看已下載的模型</a:t>
-            </a:r>
-          </a:p>
-          <a:p>
-            <a:pPr>
+              <a:t>$ ai-review config set ollama model llama3.2</a:t>
+            </a:r>
+          </a:p>
+          <a:p>
+            <a:pPr lvl="1">
               <a:spcBef>
                 <a:spcPts val="600"/>
               </a:spcBef>
               <a:spcAft>
                 <a:spcPts val="200"/>
               </a:spcAft>
-              <a:defRPr sz="600" b="0">
+              <a:defRPr sz="1400" b="0">
+                <a:solidFill>
+                  <a:srgbClr val="A6E3A1"/>
+                </a:solidFill>
+              </a:defRPr>
+            </a:pPr>
+            <a:r>
+              <a:t>$ ai-review hook enable</a:t>
+            </a:r>
+          </a:p>
+          <a:p>
+            <a:pPr>
+              <a:spcBef>
+                <a:spcPts val="600"/>
+              </a:spcBef>
+              <a:spcAft>
+                <a:spcPts val="200"/>
+              </a:spcAft>
+              <a:defRPr sz="800" b="0">
                 <a:solidFill>
                   <a:srgbClr val="CDD6F4"/>
                 </a:solidFill>
@@ -6863,7 +6792,7 @@
               </a:defRPr>
             </a:pPr>
             <a:r>
-              <a:t>切換 ai-review 使用的 Model</a:t>
+              <a:t>日常使用 — hooks 自動運作</a:t>
             </a:r>
           </a:p>
           <a:p>
@@ -6881,7 +6810,7 @@
               </a:defRPr>
             </a:pPr>
             <a:r>
-              <a:t>$ ai-review config set ollama model llama3.2</a:t>
+              <a:t>$ git add main.py</a:t>
             </a:r>
           </a:p>
           <a:p>
@@ -6899,40 +6828,43 @@
               </a:defRPr>
             </a:pPr>
             <a:r>
-              <a:t>$ ai-review health-check                   # 驗證</a:t>
-            </a:r>
-          </a:p>
-          <a:p>
-            <a:pPr>
+              <a:t>$ git commit          → 互動選單自動出現</a:t>
+            </a:r>
+          </a:p>
+          <a:p>
+            <a:pPr lvl="2">
               <a:spcBef>
                 <a:spcPts val="600"/>
               </a:spcBef>
               <a:spcAft>
                 <a:spcPts val="200"/>
               </a:spcAft>
-              <a:defRPr sz="600" b="0">
-                <a:solidFill>
-                  <a:srgbClr val="CDD6F4"/>
-                </a:solidFill>
-              </a:defRPr>
-            </a:pPr>
-          </a:p>
-          <a:p>
-            <a:pPr>
+              <a:defRPr sz="1400" b="0">
+                <a:solidFill>
+                  <a:srgbClr val="6C7086"/>
+                </a:solidFill>
+              </a:defRPr>
+            </a:pPr>
+            <a:r>
+              <a:t>                      → 編輯器確認 message</a:t>
+            </a:r>
+          </a:p>
+          <a:p>
+            <a:pPr lvl="2">
               <a:spcBef>
                 <a:spcPts val="600"/>
               </a:spcBef>
               <a:spcAft>
                 <a:spcPts val="200"/>
               </a:spcAft>
-              <a:defRPr sz="1800" b="1">
-                <a:solidFill>
-                  <a:srgbClr val="89B4FA"/>
-                </a:solidFill>
-              </a:defRPr>
-            </a:pPr>
-            <a:r>
-              <a:t>臨時切換（不改設定）</a:t>
+              <a:defRPr sz="1400" b="0">
+                <a:solidFill>
+                  <a:srgbClr val="6C7086"/>
+                </a:solidFill>
+              </a:defRPr>
+            </a:pPr>
+            <a:r>
+              <a:t>                      → 格式自動檢查</a:t>
             </a:r>
           </a:p>
           <a:p>
@@ -6950,39 +6882,47 @@
               </a:defRPr>
             </a:pPr>
             <a:r>
-              <a:t>$ ai-review --model codellama</a:t>
-            </a:r>
-          </a:p>
-          <a:p>
-            <a:pPr lvl="1">
-              <a:spcBef>
-                <a:spcPts val="600"/>
-              </a:spcBef>
-              <a:spcAft>
-                <a:spcPts val="200"/>
-              </a:spcAft>
-              <a:defRPr sz="1400" b="0">
-                <a:solidFill>
-                  <a:srgbClr val="A6E3A1"/>
-                </a:solidFill>
-              </a:defRPr>
-            </a:pPr>
-            <a:r>
-              <a:t>$ ai-review --provider openai --model gpt-4o</a:t>
-            </a:r>
-          </a:p>
-        </p:txBody>
-      </p:sp>
-      <p:sp>
-        <p:nvSpPr>
-          <p:cNvPr id="5" name="TextBox 4"/>
+              <a:t>$ git push            → pre-push AI 審查</a:t>
+            </a:r>
+          </a:p>
+        </p:txBody>
+      </p:sp>
+    </p:spTree>
+  </p:cSld>
+  <p:clrMapOvr>
+    <a:masterClrMapping/>
+  </p:clrMapOvr>
+</p:sld>
+</file>
+
+<file path=ppt/slides/slide22.xml><?xml version="1.0" encoding="utf-8"?>
+<p:sld xmlns:a="http://schemas.openxmlformats.org/drawingml/2006/main" xmlns:p="http://schemas.openxmlformats.org/presentationml/2006/main" xmlns:r="http://schemas.openxmlformats.org/officeDocument/2006/relationships">
+  <p:cSld>
+    <p:bg>
+      <p:bgPr>
+        <a:solidFill>
+          <a:srgbClr val="1E1E2E"/>
+        </a:solidFill>
+        <a:effectLst/>
+      </p:bgPr>
+    </p:bg>
+    <p:spTree>
+      <p:nvGrpSpPr>
+        <p:cNvPr id="1" name=""/>
+        <p:cNvGrpSpPr/>
+        <p:nvPr/>
+      </p:nvGrpSpPr>
+      <p:grpSpPr/>
+      <p:sp>
+        <p:nvSpPr>
+          <p:cNvPr id="2" name="TextBox 1"/>
           <p:cNvSpPr txBox="1"/>
           <p:nvPr/>
         </p:nvSpPr>
         <p:spPr>
           <a:xfrm>
-            <a:off x="457200" y="6217920"/>
-            <a:ext cx="10972800" cy="457200"/>
+            <a:off x="457200" y="274320"/>
+            <a:ext cx="10972800" cy="640080"/>
           </a:xfrm>
           <a:prstGeom prst="rect">
             <a:avLst/>
@@ -6996,14 +6936,319 @@
           <a:lstStyle/>
           <a:p>
             <a:pPr algn="l">
-              <a:defRPr sz="1200" b="0">
+              <a:defRPr sz="2800" b="1">
+                <a:solidFill>
+                  <a:srgbClr val="89B4FA"/>
+                </a:solidFill>
+              </a:defRPr>
+            </a:pPr>
+            <a:r>
+              <a:t>8. 情境二：管理多個 Repo（BSP 團隊）</a:t>
+            </a:r>
+          </a:p>
+        </p:txBody>
+      </p:sp>
+      <p:sp>
+        <p:nvSpPr>
+          <p:cNvPr id="3" name="Rounded Rectangle 2"/>
+          <p:cNvSpPr/>
+          <p:nvPr/>
+        </p:nvSpPr>
+        <p:spPr>
+          <a:xfrm>
+            <a:off x="365760" y="1005840"/>
+            <a:ext cx="11430000" cy="5029200"/>
+          </a:xfrm>
+          <a:prstGeom prst="roundRect">
+            <a:avLst>
+              <a:gd name="adj" fmla="val 5000"/>
+            </a:avLst>
+          </a:prstGeom>
+          <a:solidFill>
+            <a:srgbClr val="31344B"/>
+          </a:solidFill>
+          <a:ln>
+            <a:noFill/>
+          </a:ln>
+        </p:spPr>
+        <p:style>
+          <a:lnRef idx="1">
+            <a:schemeClr val="accent1"/>
+          </a:lnRef>
+          <a:fillRef idx="3">
+            <a:schemeClr val="accent1"/>
+          </a:fillRef>
+          <a:effectRef idx="2">
+            <a:schemeClr val="accent1"/>
+          </a:effectRef>
+          <a:fontRef idx="minor">
+            <a:schemeClr val="lt1"/>
+          </a:fontRef>
+        </p:style>
+        <p:txBody>
+          <a:bodyPr rtlCol="0" anchor="ctr"/>
+          <a:lstStyle/>
+          <a:p>
+            <a:pPr algn="ctr"/>
+          </a:p>
+        </p:txBody>
+      </p:sp>
+      <p:sp>
+        <p:nvSpPr>
+          <p:cNvPr id="4" name="TextBox 3"/>
+          <p:cNvSpPr txBox="1"/>
+          <p:nvPr/>
+        </p:nvSpPr>
+        <p:spPr>
+          <a:xfrm>
+            <a:off x="640080" y="1188720"/>
+            <a:ext cx="10972800" cy="4754880"/>
+          </a:xfrm>
+          <a:prstGeom prst="rect">
+            <a:avLst/>
+          </a:prstGeom>
+          <a:noFill/>
+        </p:spPr>
+        <p:txBody>
+          <a:bodyPr wrap="square">
+            <a:spAutoFit/>
+          </a:bodyPr>
+          <a:lstStyle/>
+          <a:p>
+            <a:pPr algn="l">
+              <a:defRPr sz="1800" b="1">
+                <a:solidFill>
+                  <a:srgbClr val="89B4FA"/>
+                </a:solidFill>
+              </a:defRPr>
+            </a:pPr>
+            <a:r>
+              <a:t>預覽所有 repo 狀態</a:t>
+            </a:r>
+          </a:p>
+          <a:p>
+            <a:pPr lvl="1">
+              <a:spcBef>
+                <a:spcPts val="600"/>
+              </a:spcBef>
+              <a:spcAft>
+                <a:spcPts val="200"/>
+              </a:spcAft>
+              <a:defRPr sz="1400" b="0">
+                <a:solidFill>
+                  <a:srgbClr val="A6E3A1"/>
+                </a:solidFill>
+              </a:defRPr>
+            </a:pPr>
+            <a:r>
+              <a:t>$ ai-review hook enable --all /workspace --list</a:t>
+            </a:r>
+          </a:p>
+          <a:p>
+            <a:pPr lvl="1">
+              <a:spcBef>
+                <a:spcPts val="600"/>
+              </a:spcBef>
+              <a:spcAft>
+                <a:spcPts val="200"/>
+              </a:spcAft>
+              <a:defRPr sz="1300" b="0">
                 <a:solidFill>
                   <a:srgbClr val="6C7086"/>
                 </a:solidFill>
               </a:defRPr>
             </a:pPr>
             <a:r>
-              <a:t>小模型（3B）速度快但可能誤報 ｜ 大模型（7B+）品質好但較慢</a:t>
+              <a:t>  camera-hal: disabled    audio-hal: disabled</a:t>
+            </a:r>
+          </a:p>
+          <a:p>
+            <a:pPr lvl="1">
+              <a:spcBef>
+                <a:spcPts val="600"/>
+              </a:spcBef>
+              <a:spcAft>
+                <a:spcPts val="200"/>
+              </a:spcAft>
+              <a:defRPr sz="1300" b="0">
+                <a:solidFill>
+                  <a:srgbClr val="6C7086"/>
+                </a:solidFill>
+              </a:defRPr>
+            </a:pPr>
+            <a:r>
+              <a:t>  kernel: disabled        framework: disabled</a:t>
+            </a:r>
+          </a:p>
+          <a:p>
+            <a:pPr>
+              <a:spcBef>
+                <a:spcPts val="600"/>
+              </a:spcBef>
+              <a:spcAft>
+                <a:spcPts val="200"/>
+              </a:spcAft>
+              <a:defRPr sz="800" b="0">
+                <a:solidFill>
+                  <a:srgbClr val="CDD6F4"/>
+                </a:solidFill>
+              </a:defRPr>
+            </a:pPr>
+          </a:p>
+          <a:p>
+            <a:pPr>
+              <a:spcBef>
+                <a:spcPts val="600"/>
+              </a:spcBef>
+              <a:spcAft>
+                <a:spcPts val="200"/>
+              </a:spcAft>
+              <a:defRPr sz="1800" b="1">
+                <a:solidFill>
+                  <a:srgbClr val="A6E3A1"/>
+                </a:solidFill>
+              </a:defRPr>
+            </a:pPr>
+            <a:r>
+              <a:t>批量啟用</a:t>
+            </a:r>
+          </a:p>
+          <a:p>
+            <a:pPr lvl="1">
+              <a:spcBef>
+                <a:spcPts val="600"/>
+              </a:spcBef>
+              <a:spcAft>
+                <a:spcPts val="200"/>
+              </a:spcAft>
+              <a:defRPr sz="1400" b="0">
+                <a:solidFill>
+                  <a:srgbClr val="A6E3A1"/>
+                </a:solidFill>
+              </a:defRPr>
+            </a:pPr>
+            <a:r>
+              <a:t>$ ai-review hook enable --all /workspace</a:t>
+            </a:r>
+          </a:p>
+          <a:p>
+            <a:pPr>
+              <a:spcBef>
+                <a:spcPts val="600"/>
+              </a:spcBef>
+              <a:spcAft>
+                <a:spcPts val="200"/>
+              </a:spcAft>
+              <a:defRPr sz="600" b="0">
+                <a:solidFill>
+                  <a:srgbClr val="CDD6F4"/>
+                </a:solidFill>
+              </a:defRPr>
+            </a:pPr>
+          </a:p>
+          <a:p>
+            <a:pPr>
+              <a:spcBef>
+                <a:spcPts val="600"/>
+              </a:spcBef>
+              <a:spcAft>
+                <a:spcPts val="200"/>
+              </a:spcAft>
+              <a:defRPr sz="1800" b="1">
+                <a:solidFill>
+                  <a:srgbClr val="FAB387"/>
+                </a:solidFill>
+              </a:defRPr>
+            </a:pPr>
+            <a:r>
+              <a:t>啟用特定 repo</a:t>
+            </a:r>
+          </a:p>
+          <a:p>
+            <a:pPr lvl="1">
+              <a:spcBef>
+                <a:spcPts val="600"/>
+              </a:spcBef>
+              <a:spcAft>
+                <a:spcPts val="200"/>
+              </a:spcAft>
+              <a:defRPr sz="1400" b="0">
+                <a:solidFill>
+                  <a:srgbClr val="FAB387"/>
+                </a:solidFill>
+              </a:defRPr>
+            </a:pPr>
+            <a:r>
+              <a:t>$ ai-review hook enable --path /workspace/camera-hal \</a:t>
+            </a:r>
+          </a:p>
+          <a:p>
+            <a:pPr lvl="1">
+              <a:spcBef>
+                <a:spcPts val="600"/>
+              </a:spcBef>
+              <a:spcAft>
+                <a:spcPts val="200"/>
+              </a:spcAft>
+              <a:defRPr sz="1400" b="0">
+                <a:solidFill>
+                  <a:srgbClr val="FAB387"/>
+                </a:solidFill>
+              </a:defRPr>
+            </a:pPr>
+            <a:r>
+              <a:t>                        --path /workspace/kernel</a:t>
+            </a:r>
+          </a:p>
+          <a:p>
+            <a:pPr>
+              <a:spcBef>
+                <a:spcPts val="600"/>
+              </a:spcBef>
+              <a:spcAft>
+                <a:spcPts val="200"/>
+              </a:spcAft>
+              <a:defRPr sz="600" b="0">
+                <a:solidFill>
+                  <a:srgbClr val="CDD6F4"/>
+                </a:solidFill>
+              </a:defRPr>
+            </a:pPr>
+          </a:p>
+          <a:p>
+            <a:pPr>
+              <a:spcBef>
+                <a:spcPts val="600"/>
+              </a:spcBef>
+              <a:spcAft>
+                <a:spcPts val="200"/>
+              </a:spcAft>
+              <a:defRPr sz="1800" b="1">
+                <a:solidFill>
+                  <a:srgbClr val="74C7EC"/>
+                </a:solidFill>
+              </a:defRPr>
+            </a:pPr>
+            <a:r>
+              <a:t>停用特定 repo</a:t>
+            </a:r>
+          </a:p>
+          <a:p>
+            <a:pPr lvl="1">
+              <a:spcBef>
+                <a:spcPts val="600"/>
+              </a:spcBef>
+              <a:spcAft>
+                <a:spcPts val="200"/>
+              </a:spcAft>
+              <a:defRPr sz="1400" b="0">
+                <a:solidFill>
+                  <a:srgbClr val="74C7EC"/>
+                </a:solidFill>
+              </a:defRPr>
+            </a:pPr>
+            <a:r>
+              <a:t>$ ai-review hook disable --path /workspace/kernel</a:t>
             </a:r>
           </a:p>
         </p:txBody>
@@ -7064,7 +7309,1282 @@
               </a:defRPr>
             </a:pPr>
             <a:r>
-              <a:t>8. 模型比較</a:t>
+              <a:t>8. 情境三：團隊共用 LLM Server</a:t>
+            </a:r>
+          </a:p>
+        </p:txBody>
+      </p:sp>
+      <p:sp>
+        <p:nvSpPr>
+          <p:cNvPr id="3" name="Rounded Rectangle 2"/>
+          <p:cNvSpPr/>
+          <p:nvPr/>
+        </p:nvSpPr>
+        <p:spPr>
+          <a:xfrm>
+            <a:off x="365760" y="1005840"/>
+            <a:ext cx="11430000" cy="5029200"/>
+          </a:xfrm>
+          <a:prstGeom prst="roundRect">
+            <a:avLst>
+              <a:gd name="adj" fmla="val 5000"/>
+            </a:avLst>
+          </a:prstGeom>
+          <a:solidFill>
+            <a:srgbClr val="31344B"/>
+          </a:solidFill>
+          <a:ln>
+            <a:noFill/>
+          </a:ln>
+        </p:spPr>
+        <p:style>
+          <a:lnRef idx="1">
+            <a:schemeClr val="accent1"/>
+          </a:lnRef>
+          <a:fillRef idx="3">
+            <a:schemeClr val="accent1"/>
+          </a:fillRef>
+          <a:effectRef idx="2">
+            <a:schemeClr val="accent1"/>
+          </a:effectRef>
+          <a:fontRef idx="minor">
+            <a:schemeClr val="lt1"/>
+          </a:fontRef>
+        </p:style>
+        <p:txBody>
+          <a:bodyPr rtlCol="0" anchor="ctr"/>
+          <a:lstStyle/>
+          <a:p>
+            <a:pPr algn="ctr"/>
+          </a:p>
+        </p:txBody>
+      </p:sp>
+      <p:sp>
+        <p:nvSpPr>
+          <p:cNvPr id="4" name="TextBox 3"/>
+          <p:cNvSpPr txBox="1"/>
+          <p:nvPr/>
+        </p:nvSpPr>
+        <p:spPr>
+          <a:xfrm>
+            <a:off x="640080" y="1188720"/>
+            <a:ext cx="10972800" cy="4754880"/>
+          </a:xfrm>
+          <a:prstGeom prst="rect">
+            <a:avLst/>
+          </a:prstGeom>
+          <a:noFill/>
+        </p:spPr>
+        <p:txBody>
+          <a:bodyPr wrap="square">
+            <a:spAutoFit/>
+          </a:bodyPr>
+          <a:lstStyle/>
+          <a:p>
+            <a:pPr algn="l">
+              <a:defRPr sz="1800" b="1">
+                <a:solidFill>
+                  <a:srgbClr val="89B4FA"/>
+                </a:solidFill>
+              </a:defRPr>
+            </a:pPr>
+            <a:r>
+              <a:t>架構</a:t>
+            </a:r>
+          </a:p>
+          <a:p>
+            <a:pPr>
+              <a:spcBef>
+                <a:spcPts val="600"/>
+              </a:spcBef>
+              <a:spcAft>
+                <a:spcPts val="200"/>
+              </a:spcAft>
+              <a:defRPr sz="1500" b="0">
+                <a:solidFill>
+                  <a:srgbClr val="74C7EC"/>
+                </a:solidFill>
+              </a:defRPr>
+            </a:pPr>
+            <a:r>
+              <a:t>  開發機 A (Windows) ──→</a:t>
+            </a:r>
+          </a:p>
+          <a:p>
+            <a:pPr>
+              <a:spcBef>
+                <a:spcPts val="600"/>
+              </a:spcBef>
+              <a:spcAft>
+                <a:spcPts val="200"/>
+              </a:spcAft>
+              <a:defRPr sz="1500" b="0">
+                <a:solidFill>
+                  <a:srgbClr val="F5C2E7"/>
+                </a:solidFill>
+              </a:defRPr>
+            </a:pPr>
+            <a:r>
+              <a:t>  開發機 B (macOS)   ──→  LLM Server (192.168.1.100)</a:t>
+            </a:r>
+          </a:p>
+          <a:p>
+            <a:pPr>
+              <a:spcBef>
+                <a:spcPts val="600"/>
+              </a:spcBef>
+              <a:spcAft>
+                <a:spcPts val="200"/>
+              </a:spcAft>
+              <a:defRPr sz="1500" b="0">
+                <a:solidFill>
+                  <a:srgbClr val="A6E3A1"/>
+                </a:solidFill>
+              </a:defRPr>
+            </a:pPr>
+            <a:r>
+              <a:t>  開發機 C (Linux)   ──→  Ollama + GPU</a:t>
+            </a:r>
+          </a:p>
+          <a:p>
+            <a:pPr>
+              <a:spcBef>
+                <a:spcPts val="600"/>
+              </a:spcBef>
+              <a:spcAft>
+                <a:spcPts val="200"/>
+              </a:spcAft>
+              <a:defRPr sz="1000" b="0">
+                <a:solidFill>
+                  <a:srgbClr val="CDD6F4"/>
+                </a:solidFill>
+              </a:defRPr>
+            </a:pPr>
+          </a:p>
+          <a:p>
+            <a:pPr>
+              <a:spcBef>
+                <a:spcPts val="600"/>
+              </a:spcBef>
+              <a:spcAft>
+                <a:spcPts val="200"/>
+              </a:spcAft>
+              <a:defRPr sz="1800" b="1">
+                <a:solidFill>
+                  <a:srgbClr val="FAB387"/>
+                </a:solidFill>
+              </a:defRPr>
+            </a:pPr>
+            <a:r>
+              <a:t>Server 端（一次）</a:t>
+            </a:r>
+          </a:p>
+          <a:p>
+            <a:pPr lvl="1">
+              <a:spcBef>
+                <a:spcPts val="600"/>
+              </a:spcBef>
+              <a:spcAft>
+                <a:spcPts val="200"/>
+              </a:spcAft>
+              <a:defRPr sz="1400" b="0">
+                <a:solidFill>
+                  <a:srgbClr val="FAB387"/>
+                </a:solidFill>
+              </a:defRPr>
+            </a:pPr>
+            <a:r>
+              <a:t>$ sudo systemctl edit ollama</a:t>
+            </a:r>
+          </a:p>
+          <a:p>
+            <a:pPr lvl="1">
+              <a:spcBef>
+                <a:spcPts val="600"/>
+              </a:spcBef>
+              <a:spcAft>
+                <a:spcPts val="200"/>
+              </a:spcAft>
+              <a:defRPr sz="1300" b="0">
+                <a:solidFill>
+                  <a:srgbClr val="6C7086"/>
+                </a:solidFill>
+              </a:defRPr>
+            </a:pPr>
+            <a:r>
+              <a:t>  加入 Environment="OLLAMA_HOST=0.0.0.0"</a:t>
+            </a:r>
+          </a:p>
+          <a:p>
+            <a:pPr lvl="1">
+              <a:spcBef>
+                <a:spcPts val="600"/>
+              </a:spcBef>
+              <a:spcAft>
+                <a:spcPts val="200"/>
+              </a:spcAft>
+              <a:defRPr sz="1400" b="0">
+                <a:solidFill>
+                  <a:srgbClr val="FAB387"/>
+                </a:solidFill>
+              </a:defRPr>
+            </a:pPr>
+            <a:r>
+              <a:t>$ sudo systemctl restart ollama</a:t>
+            </a:r>
+          </a:p>
+          <a:p>
+            <a:pPr>
+              <a:spcBef>
+                <a:spcPts val="600"/>
+              </a:spcBef>
+              <a:spcAft>
+                <a:spcPts val="200"/>
+              </a:spcAft>
+              <a:defRPr sz="600" b="0">
+                <a:solidFill>
+                  <a:srgbClr val="CDD6F4"/>
+                </a:solidFill>
+              </a:defRPr>
+            </a:pPr>
+          </a:p>
+          <a:p>
+            <a:pPr>
+              <a:spcBef>
+                <a:spcPts val="600"/>
+              </a:spcBef>
+              <a:spcAft>
+                <a:spcPts val="200"/>
+              </a:spcAft>
+              <a:defRPr sz="1800" b="1">
+                <a:solidFill>
+                  <a:srgbClr val="A6E3A1"/>
+                </a:solidFill>
+              </a:defRPr>
+            </a:pPr>
+            <a:r>
+              <a:t>每台開發機（一次）</a:t>
+            </a:r>
+          </a:p>
+          <a:p>
+            <a:pPr lvl="1">
+              <a:spcBef>
+                <a:spcPts val="600"/>
+              </a:spcBef>
+              <a:spcAft>
+                <a:spcPts val="200"/>
+              </a:spcAft>
+              <a:defRPr sz="1400" b="0">
+                <a:solidFill>
+                  <a:srgbClr val="A6E3A1"/>
+                </a:solidFill>
+              </a:defRPr>
+            </a:pPr>
+            <a:r>
+              <a:t>$ ai-review config set ollama base_url http://192.168.1.100:11434</a:t>
+            </a:r>
+          </a:p>
+          <a:p>
+            <a:pPr lvl="1">
+              <a:spcBef>
+                <a:spcPts val="600"/>
+              </a:spcBef>
+              <a:spcAft>
+                <a:spcPts val="200"/>
+              </a:spcAft>
+              <a:defRPr sz="1400" b="0">
+                <a:solidFill>
+                  <a:srgbClr val="A6E3A1"/>
+                </a:solidFill>
+              </a:defRPr>
+            </a:pPr>
+            <a:r>
+              <a:t>$ ai-review health-check</a:t>
+            </a:r>
+          </a:p>
+        </p:txBody>
+      </p:sp>
+    </p:spTree>
+  </p:cSld>
+  <p:clrMapOvr>
+    <a:masterClrMapping/>
+  </p:clrMapOvr>
+</p:sld>
+</file>
+
+<file path=ppt/slides/slide24.xml><?xml version="1.0" encoding="utf-8"?>
+<p:sld xmlns:a="http://schemas.openxmlformats.org/drawingml/2006/main" xmlns:p="http://schemas.openxmlformats.org/presentationml/2006/main" xmlns:r="http://schemas.openxmlformats.org/officeDocument/2006/relationships">
+  <p:cSld>
+    <p:bg>
+      <p:bgPr>
+        <a:solidFill>
+          <a:srgbClr val="1E1E2E"/>
+        </a:solidFill>
+        <a:effectLst/>
+      </p:bgPr>
+    </p:bg>
+    <p:spTree>
+      <p:nvGrpSpPr>
+        <p:cNvPr id="1" name=""/>
+        <p:cNvGrpSpPr/>
+        <p:nvPr/>
+      </p:nvGrpSpPr>
+      <p:grpSpPr/>
+      <p:sp>
+        <p:nvSpPr>
+          <p:cNvPr id="2" name="TextBox 1"/>
+          <p:cNvSpPr txBox="1"/>
+          <p:nvPr/>
+        </p:nvSpPr>
+        <p:spPr>
+          <a:xfrm>
+            <a:off x="457200" y="274320"/>
+            <a:ext cx="10972800" cy="640080"/>
+          </a:xfrm>
+          <a:prstGeom prst="rect">
+            <a:avLst/>
+          </a:prstGeom>
+          <a:noFill/>
+        </p:spPr>
+        <p:txBody>
+          <a:bodyPr wrap="square">
+            <a:spAutoFit/>
+          </a:bodyPr>
+          <a:lstStyle/>
+          <a:p>
+            <a:pPr algn="l">
+              <a:defRPr sz="2800" b="1">
+                <a:solidFill>
+                  <a:srgbClr val="89B4FA"/>
+                </a:solidFill>
+              </a:defRPr>
+            </a:pPr>
+            <a:r>
+              <a:t>8. 情境四：Commit 互動選單怎麼選</a:t>
+            </a:r>
+          </a:p>
+        </p:txBody>
+      </p:sp>
+      <p:graphicFrame>
+        <p:nvGraphicFramePr>
+          <p:cNvPr id="3" name="Table 2"/>
+          <p:cNvGraphicFramePr>
+            <a:graphicFrameLocks noGrp="1"/>
+          </p:cNvGraphicFramePr>
+          <p:nvPr/>
+        </p:nvGraphicFramePr>
+        <p:xfrm>
+          <a:off x="594360" y="1097280"/>
+          <a:ext cx="10972800" cy="2743200"/>
+        </p:xfrm>
+        <a:graphic>
+          <a:graphicData uri="http://schemas.openxmlformats.org/drawingml/2006/table">
+            <a:tbl>
+              <a:tblPr firstRow="1" bandRow="1">
+                <a:tableStyleId>{5C22544A-7EE6-4342-B048-85BDC9FD1C3A}</a:tableStyleId>
+              </a:tblPr>
+              <a:tblGrid>
+                <a:gridCol w="3657600"/>
+                <a:gridCol w="3657600"/>
+                <a:gridCol w="3657600"/>
+              </a:tblGrid>
+              <a:tr h="548640">
+                <a:tc>
+                  <a:txBody>
+                    <a:bodyPr/>
+                    <a:lstStyle/>
+                    <a:p>
+                      <a:pPr>
+                        <a:defRPr sz="1400" b="1">
+                          <a:solidFill>
+                            <a:srgbClr val="1E1E2E"/>
+                          </a:solidFill>
+                        </a:defRPr>
+                      </a:pPr>
+                      <a:r>
+                        <a:t>選項</a:t>
+                      </a:r>
+                    </a:p>
+                  </a:txBody>
+                  <a:tcPr>
+                    <a:solidFill>
+                      <a:srgbClr val="89B4FA"/>
+                    </a:solidFill>
+                  </a:tcPr>
+                </a:tc>
+                <a:tc>
+                  <a:txBody>
+                    <a:bodyPr/>
+                    <a:lstStyle/>
+                    <a:p>
+                      <a:pPr>
+                        <a:defRPr sz="1400" b="1">
+                          <a:solidFill>
+                            <a:srgbClr val="1E1E2E"/>
+                          </a:solidFill>
+                        </a:defRPr>
+                      </a:pPr>
+                      <a:r>
+                        <a:t>適合什麼時候</a:t>
+                      </a:r>
+                    </a:p>
+                  </a:txBody>
+                  <a:tcPr>
+                    <a:solidFill>
+                      <a:srgbClr val="89B4FA"/>
+                    </a:solidFill>
+                  </a:tcPr>
+                </a:tc>
+                <a:tc>
+                  <a:txBody>
+                    <a:bodyPr/>
+                    <a:lstStyle/>
+                    <a:p>
+                      <a:pPr>
+                        <a:defRPr sz="1400" b="1">
+                          <a:solidFill>
+                            <a:srgbClr val="1E1E2E"/>
+                          </a:solidFill>
+                        </a:defRPr>
+                      </a:pPr>
+                      <a:r>
+                        <a:t>說明</a:t>
+                      </a:r>
+                    </a:p>
+                  </a:txBody>
+                  <a:tcPr>
+                    <a:solidFill>
+                      <a:srgbClr val="89B4FA"/>
+                    </a:solidFill>
+                  </a:tcPr>
+                </a:tc>
+              </a:tr>
+              <a:tr h="548640">
+                <a:tc>
+                  <a:txBody>
+                    <a:bodyPr/>
+                    <a:lstStyle/>
+                    <a:p>
+                      <a:pPr>
+                        <a:defRPr sz="1300">
+                          <a:solidFill>
+                            <a:srgbClr val="CDD6F4"/>
+                          </a:solidFill>
+                        </a:defRPr>
+                      </a:pPr>
+                      <a:r>
+                        <a:t>1 Load template</a:t>
+                      </a:r>
+                    </a:p>
+                  </a:txBody>
+                  <a:tcPr>
+                    <a:solidFill>
+                      <a:srgbClr val="31344B"/>
+                    </a:solidFill>
+                  </a:tcPr>
+                </a:tc>
+                <a:tc>
+                  <a:txBody>
+                    <a:bodyPr/>
+                    <a:lstStyle/>
+                    <a:p>
+                      <a:pPr>
+                        <a:defRPr sz="1300">
+                          <a:solidFill>
+                            <a:srgbClr val="CDD6F4"/>
+                          </a:solidFill>
+                        </a:defRPr>
+                      </a:pPr>
+                      <a:r>
+                        <a:t>忘了格式</a:t>
+                      </a:r>
+                    </a:p>
+                  </a:txBody>
+                  <a:tcPr>
+                    <a:solidFill>
+                      <a:srgbClr val="31344B"/>
+                    </a:solidFill>
+                  </a:tcPr>
+                </a:tc>
+                <a:tc>
+                  <a:txBody>
+                    <a:bodyPr/>
+                    <a:lstStyle/>
+                    <a:p>
+                      <a:pPr>
+                        <a:defRPr sz="1300">
+                          <a:solidFill>
+                            <a:srgbClr val="CDD6F4"/>
+                          </a:solidFill>
+                        </a:defRPr>
+                      </a:pPr>
+                      <a:r>
+                        <a:t>載入模板填寫</a:t>
+                      </a:r>
+                    </a:p>
+                  </a:txBody>
+                  <a:tcPr>
+                    <a:solidFill>
+                      <a:srgbClr val="31344B"/>
+                    </a:solidFill>
+                  </a:tcPr>
+                </a:tc>
+              </a:tr>
+              <a:tr h="548640">
+                <a:tc>
+                  <a:txBody>
+                    <a:bodyPr/>
+                    <a:lstStyle/>
+                    <a:p>
+                      <a:pPr>
+                        <a:defRPr sz="1300">
+                          <a:solidFill>
+                            <a:srgbClr val="CDD6F4"/>
+                          </a:solidFill>
+                        </a:defRPr>
+                      </a:pPr>
+                      <a:r>
+                        <a:t>2 LLM optimize</a:t>
+                      </a:r>
+                    </a:p>
+                  </a:txBody>
+                  <a:tcPr>
+                    <a:solidFill>
+                      <a:srgbClr val="24273A"/>
+                    </a:solidFill>
+                  </a:tcPr>
+                </a:tc>
+                <a:tc>
+                  <a:txBody>
+                    <a:bodyPr/>
+                    <a:lstStyle/>
+                    <a:p>
+                      <a:pPr>
+                        <a:defRPr sz="1300">
+                          <a:solidFill>
+                            <a:srgbClr val="CDD6F4"/>
+                          </a:solidFill>
+                        </a:defRPr>
+                      </a:pPr>
+                      <a:r>
+                        <a:t>有草稿想潤飾</a:t>
+                      </a:r>
+                    </a:p>
+                  </a:txBody>
+                  <a:tcPr>
+                    <a:solidFill>
+                      <a:srgbClr val="24273A"/>
+                    </a:solidFill>
+                  </a:tcPr>
+                </a:tc>
+                <a:tc>
+                  <a:txBody>
+                    <a:bodyPr/>
+                    <a:lstStyle/>
+                    <a:p>
+                      <a:pPr>
+                        <a:defRPr sz="1300">
+                          <a:solidFill>
+                            <a:srgbClr val="CDD6F4"/>
+                          </a:solidFill>
+                        </a:defRPr>
+                      </a:pPr>
+                      <a:r>
+                        <a:t>AI 優化現有文字</a:t>
+                      </a:r>
+                    </a:p>
+                  </a:txBody>
+                  <a:tcPr>
+                    <a:solidFill>
+                      <a:srgbClr val="24273A"/>
+                    </a:solidFill>
+                  </a:tcPr>
+                </a:tc>
+              </a:tr>
+              <a:tr h="548640">
+                <a:tc>
+                  <a:txBody>
+                    <a:bodyPr/>
+                    <a:lstStyle/>
+                    <a:p>
+                      <a:pPr>
+                        <a:defRPr sz="1300">
+                          <a:solidFill>
+                            <a:srgbClr val="CDD6F4"/>
+                          </a:solidFill>
+                        </a:defRPr>
+                      </a:pPr>
+                      <a:r>
+                        <a:t>3 LLM auto-generate</a:t>
+                      </a:r>
+                    </a:p>
+                  </a:txBody>
+                  <a:tcPr>
+                    <a:solidFill>
+                      <a:srgbClr val="31344B"/>
+                    </a:solidFill>
+                  </a:tcPr>
+                </a:tc>
+                <a:tc>
+                  <a:txBody>
+                    <a:bodyPr/>
+                    <a:lstStyle/>
+                    <a:p>
+                      <a:pPr>
+                        <a:defRPr sz="1300">
+                          <a:solidFill>
+                            <a:srgbClr val="CDD6F4"/>
+                          </a:solidFill>
+                        </a:defRPr>
+                      </a:pPr>
+                      <a:r>
+                        <a:t>懶得寫</a:t>
+                      </a:r>
+                    </a:p>
+                  </a:txBody>
+                  <a:tcPr>
+                    <a:solidFill>
+                      <a:srgbClr val="31344B"/>
+                    </a:solidFill>
+                  </a:tcPr>
+                </a:tc>
+                <a:tc>
+                  <a:txBody>
+                    <a:bodyPr/>
+                    <a:lstStyle/>
+                    <a:p>
+                      <a:pPr>
+                        <a:defRPr sz="1300">
+                          <a:solidFill>
+                            <a:srgbClr val="CDD6F4"/>
+                          </a:solidFill>
+                        </a:defRPr>
+                      </a:pPr>
+                      <a:r>
+                        <a:t>AI 看 diff 自動生成</a:t>
+                      </a:r>
+                    </a:p>
+                  </a:txBody>
+                  <a:tcPr>
+                    <a:solidFill>
+                      <a:srgbClr val="31344B"/>
+                    </a:solidFill>
+                  </a:tcPr>
+                </a:tc>
+              </a:tr>
+              <a:tr h="548640">
+                <a:tc>
+                  <a:txBody>
+                    <a:bodyPr/>
+                    <a:lstStyle/>
+                    <a:p>
+                      <a:pPr>
+                        <a:defRPr sz="1300">
+                          <a:solidFill>
+                            <a:srgbClr val="CDD6F4"/>
+                          </a:solidFill>
+                        </a:defRPr>
+                      </a:pPr>
+                      <a:r>
+                        <a:t>s Skip</a:t>
+                      </a:r>
+                    </a:p>
+                  </a:txBody>
+                  <a:tcPr>
+                    <a:solidFill>
+                      <a:srgbClr val="24273A"/>
+                    </a:solidFill>
+                  </a:tcPr>
+                </a:tc>
+                <a:tc>
+                  <a:txBody>
+                    <a:bodyPr/>
+                    <a:lstStyle/>
+                    <a:p>
+                      <a:pPr>
+                        <a:defRPr sz="1300">
+                          <a:solidFill>
+                            <a:srgbClr val="CDD6F4"/>
+                          </a:solidFill>
+                        </a:defRPr>
+                      </a:pPr>
+                      <a:r>
+                        <a:t>自己寫</a:t>
+                      </a:r>
+                    </a:p>
+                  </a:txBody>
+                  <a:tcPr>
+                    <a:solidFill>
+                      <a:srgbClr val="24273A"/>
+                    </a:solidFill>
+                  </a:tcPr>
+                </a:tc>
+                <a:tc>
+                  <a:txBody>
+                    <a:bodyPr/>
+                    <a:lstStyle/>
+                    <a:p>
+                      <a:pPr>
+                        <a:defRPr sz="1300">
+                          <a:solidFill>
+                            <a:srgbClr val="CDD6F4"/>
+                          </a:solidFill>
+                        </a:defRPr>
+                      </a:pPr>
+                      <a:r>
+                        <a:t>直接進編輯器</a:t>
+                      </a:r>
+                    </a:p>
+                  </a:txBody>
+                  <a:tcPr>
+                    <a:solidFill>
+                      <a:srgbClr val="24273A"/>
+                    </a:solidFill>
+                  </a:tcPr>
+                </a:tc>
+              </a:tr>
+            </a:tbl>
+          </a:graphicData>
+        </a:graphic>
+      </p:graphicFrame>
+    </p:spTree>
+  </p:cSld>
+  <p:clrMapOvr>
+    <a:masterClrMapping/>
+  </p:clrMapOvr>
+</p:sld>
+</file>
+
+<file path=ppt/slides/slide25.xml><?xml version="1.0" encoding="utf-8"?>
+<p:sld xmlns:a="http://schemas.openxmlformats.org/drawingml/2006/main" xmlns:p="http://schemas.openxmlformats.org/presentationml/2006/main" xmlns:r="http://schemas.openxmlformats.org/officeDocument/2006/relationships">
+  <p:cSld>
+    <p:bg>
+      <p:bgPr>
+        <a:solidFill>
+          <a:srgbClr val="1E1E2E"/>
+        </a:solidFill>
+        <a:effectLst/>
+      </p:bgPr>
+    </p:bg>
+    <p:spTree>
+      <p:nvGrpSpPr>
+        <p:cNvPr id="1" name=""/>
+        <p:cNvGrpSpPr/>
+        <p:nvPr/>
+      </p:nvGrpSpPr>
+      <p:grpSpPr/>
+      <p:sp>
+        <p:nvSpPr>
+          <p:cNvPr id="2" name="Oval 1"/>
+          <p:cNvSpPr/>
+          <p:nvPr/>
+        </p:nvSpPr>
+        <p:spPr>
+          <a:xfrm>
+            <a:off x="5394960" y="1828800"/>
+            <a:ext cx="1371600" cy="1371600"/>
+          </a:xfrm>
+          <a:prstGeom prst="ellipse">
+            <a:avLst/>
+          </a:prstGeom>
+          <a:solidFill>
+            <a:srgbClr val="89B4FA"/>
+          </a:solidFill>
+          <a:ln>
+            <a:noFill/>
+          </a:ln>
+        </p:spPr>
+        <p:style>
+          <a:lnRef idx="1">
+            <a:schemeClr val="accent1"/>
+          </a:lnRef>
+          <a:fillRef idx="3">
+            <a:schemeClr val="accent1"/>
+          </a:fillRef>
+          <a:effectRef idx="2">
+            <a:schemeClr val="accent1"/>
+          </a:effectRef>
+          <a:fontRef idx="minor">
+            <a:schemeClr val="lt1"/>
+          </a:fontRef>
+        </p:style>
+        <p:txBody>
+          <a:bodyPr rtlCol="0" anchor="ctr" wrap="square"/>
+          <a:lstStyle/>
+          <a:p>
+            <a:pPr algn="ctr">
+              <a:defRPr sz="4000" b="1">
+                <a:solidFill>
+                  <a:srgbClr val="1E1E2E"/>
+                </a:solidFill>
+              </a:defRPr>
+            </a:pPr>
+            <a:r>
+              <a:t>9</a:t>
+            </a:r>
+          </a:p>
+        </p:txBody>
+      </p:sp>
+      <p:sp>
+        <p:nvSpPr>
+          <p:cNvPr id="3" name="TextBox 2"/>
+          <p:cNvSpPr txBox="1"/>
+          <p:nvPr/>
+        </p:nvSpPr>
+        <p:spPr>
+          <a:xfrm>
+            <a:off x="914400" y="3474720"/>
+            <a:ext cx="10332720" cy="1097280"/>
+          </a:xfrm>
+          <a:prstGeom prst="rect">
+            <a:avLst/>
+          </a:prstGeom>
+          <a:noFill/>
+        </p:spPr>
+        <p:txBody>
+          <a:bodyPr wrap="square">
+            <a:spAutoFit/>
+          </a:bodyPr>
+          <a:lstStyle/>
+          <a:p>
+            <a:pPr algn="ctr">
+              <a:defRPr sz="3600" b="1">
+                <a:solidFill>
+                  <a:srgbClr val="CDD6F4"/>
+                </a:solidFill>
+              </a:defRPr>
+            </a:pPr>
+            <a:r>
+              <a:t>更換/設定 LLM Model</a:t>
+            </a:r>
+          </a:p>
+        </p:txBody>
+      </p:sp>
+    </p:spTree>
+  </p:cSld>
+  <p:clrMapOvr>
+    <a:masterClrMapping/>
+  </p:clrMapOvr>
+</p:sld>
+</file>
+
+<file path=ppt/slides/slide26.xml><?xml version="1.0" encoding="utf-8"?>
+<p:sld xmlns:a="http://schemas.openxmlformats.org/drawingml/2006/main" xmlns:p="http://schemas.openxmlformats.org/presentationml/2006/main" xmlns:r="http://schemas.openxmlformats.org/officeDocument/2006/relationships">
+  <p:cSld>
+    <p:bg>
+      <p:bgPr>
+        <a:solidFill>
+          <a:srgbClr val="1E1E2E"/>
+        </a:solidFill>
+        <a:effectLst/>
+      </p:bgPr>
+    </p:bg>
+    <p:spTree>
+      <p:nvGrpSpPr>
+        <p:cNvPr id="1" name=""/>
+        <p:cNvGrpSpPr/>
+        <p:nvPr/>
+      </p:nvGrpSpPr>
+      <p:grpSpPr/>
+      <p:sp>
+        <p:nvSpPr>
+          <p:cNvPr id="2" name="TextBox 1"/>
+          <p:cNvSpPr txBox="1"/>
+          <p:nvPr/>
+        </p:nvSpPr>
+        <p:spPr>
+          <a:xfrm>
+            <a:off x="457200" y="274320"/>
+            <a:ext cx="10972800" cy="640080"/>
+          </a:xfrm>
+          <a:prstGeom prst="rect">
+            <a:avLst/>
+          </a:prstGeom>
+          <a:noFill/>
+        </p:spPr>
+        <p:txBody>
+          <a:bodyPr wrap="square">
+            <a:spAutoFit/>
+          </a:bodyPr>
+          <a:lstStyle/>
+          <a:p>
+            <a:pPr algn="l">
+              <a:defRPr sz="2800" b="1">
+                <a:solidFill>
+                  <a:srgbClr val="89B4FA"/>
+                </a:solidFill>
+              </a:defRPr>
+            </a:pPr>
+            <a:r>
+              <a:t>9. 切換 Model（全平台通用）</a:t>
+            </a:r>
+          </a:p>
+        </p:txBody>
+      </p:sp>
+      <p:sp>
+        <p:nvSpPr>
+          <p:cNvPr id="3" name="Rounded Rectangle 2"/>
+          <p:cNvSpPr/>
+          <p:nvPr/>
+        </p:nvSpPr>
+        <p:spPr>
+          <a:xfrm>
+            <a:off x="365760" y="1005840"/>
+            <a:ext cx="11430000" cy="5029200"/>
+          </a:xfrm>
+          <a:prstGeom prst="roundRect">
+            <a:avLst>
+              <a:gd name="adj" fmla="val 5000"/>
+            </a:avLst>
+          </a:prstGeom>
+          <a:solidFill>
+            <a:srgbClr val="31344B"/>
+          </a:solidFill>
+          <a:ln>
+            <a:noFill/>
+          </a:ln>
+        </p:spPr>
+        <p:style>
+          <a:lnRef idx="1">
+            <a:schemeClr val="accent1"/>
+          </a:lnRef>
+          <a:fillRef idx="3">
+            <a:schemeClr val="accent1"/>
+          </a:fillRef>
+          <a:effectRef idx="2">
+            <a:schemeClr val="accent1"/>
+          </a:effectRef>
+          <a:fontRef idx="minor">
+            <a:schemeClr val="lt1"/>
+          </a:fontRef>
+        </p:style>
+        <p:txBody>
+          <a:bodyPr rtlCol="0" anchor="ctr"/>
+          <a:lstStyle/>
+          <a:p>
+            <a:pPr algn="ctr"/>
+          </a:p>
+        </p:txBody>
+      </p:sp>
+      <p:sp>
+        <p:nvSpPr>
+          <p:cNvPr id="4" name="TextBox 3"/>
+          <p:cNvSpPr txBox="1"/>
+          <p:nvPr/>
+        </p:nvSpPr>
+        <p:spPr>
+          <a:xfrm>
+            <a:off x="640080" y="1188720"/>
+            <a:ext cx="10972800" cy="4754880"/>
+          </a:xfrm>
+          <a:prstGeom prst="rect">
+            <a:avLst/>
+          </a:prstGeom>
+          <a:noFill/>
+        </p:spPr>
+        <p:txBody>
+          <a:bodyPr wrap="square">
+            <a:spAutoFit/>
+          </a:bodyPr>
+          <a:lstStyle/>
+          <a:p>
+            <a:pPr algn="l">
+              <a:defRPr sz="1800" b="1">
+                <a:solidFill>
+                  <a:srgbClr val="89B4FA"/>
+                </a:solidFill>
+              </a:defRPr>
+            </a:pPr>
+            <a:r>
+              <a:t>下載新模型</a:t>
+            </a:r>
+          </a:p>
+          <a:p>
+            <a:pPr lvl="1">
+              <a:spcBef>
+                <a:spcPts val="600"/>
+              </a:spcBef>
+              <a:spcAft>
+                <a:spcPts val="200"/>
+              </a:spcAft>
+              <a:defRPr sz="1400" b="0">
+                <a:solidFill>
+                  <a:srgbClr val="A6E3A1"/>
+                </a:solidFill>
+              </a:defRPr>
+            </a:pPr>
+            <a:r>
+              <a:t>$ ollama pull llama3.2</a:t>
+            </a:r>
+          </a:p>
+          <a:p>
+            <a:pPr lvl="1">
+              <a:spcBef>
+                <a:spcPts val="600"/>
+              </a:spcBef>
+              <a:spcAft>
+                <a:spcPts val="200"/>
+              </a:spcAft>
+              <a:defRPr sz="1400" b="0">
+                <a:solidFill>
+                  <a:srgbClr val="A6E3A1"/>
+                </a:solidFill>
+              </a:defRPr>
+            </a:pPr>
+            <a:r>
+              <a:t>$ ollama pull llama3.1</a:t>
+            </a:r>
+          </a:p>
+          <a:p>
+            <a:pPr lvl="1">
+              <a:spcBef>
+                <a:spcPts val="600"/>
+              </a:spcBef>
+              <a:spcAft>
+                <a:spcPts val="200"/>
+              </a:spcAft>
+              <a:defRPr sz="1400" b="0">
+                <a:solidFill>
+                  <a:srgbClr val="A6E3A1"/>
+                </a:solidFill>
+              </a:defRPr>
+            </a:pPr>
+            <a:r>
+              <a:t>$ ollama list                              # 查看已下載的模型</a:t>
+            </a:r>
+          </a:p>
+          <a:p>
+            <a:pPr>
+              <a:spcBef>
+                <a:spcPts val="600"/>
+              </a:spcBef>
+              <a:spcAft>
+                <a:spcPts val="200"/>
+              </a:spcAft>
+              <a:defRPr sz="600" b="0">
+                <a:solidFill>
+                  <a:srgbClr val="CDD6F4"/>
+                </a:solidFill>
+              </a:defRPr>
+            </a:pPr>
+          </a:p>
+          <a:p>
+            <a:pPr>
+              <a:spcBef>
+                <a:spcPts val="600"/>
+              </a:spcBef>
+              <a:spcAft>
+                <a:spcPts val="200"/>
+              </a:spcAft>
+              <a:defRPr sz="1800" b="1">
+                <a:solidFill>
+                  <a:srgbClr val="89B4FA"/>
+                </a:solidFill>
+              </a:defRPr>
+            </a:pPr>
+            <a:r>
+              <a:t>切換 ai-review 使用的 Model</a:t>
+            </a:r>
+          </a:p>
+          <a:p>
+            <a:pPr lvl="1">
+              <a:spcBef>
+                <a:spcPts val="600"/>
+              </a:spcBef>
+              <a:spcAft>
+                <a:spcPts val="200"/>
+              </a:spcAft>
+              <a:defRPr sz="1400" b="0">
+                <a:solidFill>
+                  <a:srgbClr val="A6E3A1"/>
+                </a:solidFill>
+              </a:defRPr>
+            </a:pPr>
+            <a:r>
+              <a:t>$ ai-review config set ollama model llama3.2</a:t>
+            </a:r>
+          </a:p>
+          <a:p>
+            <a:pPr lvl="1">
+              <a:spcBef>
+                <a:spcPts val="600"/>
+              </a:spcBef>
+              <a:spcAft>
+                <a:spcPts val="200"/>
+              </a:spcAft>
+              <a:defRPr sz="1400" b="0">
+                <a:solidFill>
+                  <a:srgbClr val="A6E3A1"/>
+                </a:solidFill>
+              </a:defRPr>
+            </a:pPr>
+            <a:r>
+              <a:t>$ ai-review health-check                   # 驗證</a:t>
+            </a:r>
+          </a:p>
+          <a:p>
+            <a:pPr>
+              <a:spcBef>
+                <a:spcPts val="600"/>
+              </a:spcBef>
+              <a:spcAft>
+                <a:spcPts val="200"/>
+              </a:spcAft>
+              <a:defRPr sz="600" b="0">
+                <a:solidFill>
+                  <a:srgbClr val="CDD6F4"/>
+                </a:solidFill>
+              </a:defRPr>
+            </a:pPr>
+          </a:p>
+          <a:p>
+            <a:pPr>
+              <a:spcBef>
+                <a:spcPts val="600"/>
+              </a:spcBef>
+              <a:spcAft>
+                <a:spcPts val="200"/>
+              </a:spcAft>
+              <a:defRPr sz="1800" b="1">
+                <a:solidFill>
+                  <a:srgbClr val="89B4FA"/>
+                </a:solidFill>
+              </a:defRPr>
+            </a:pPr>
+            <a:r>
+              <a:t>臨時切換（不改設定）</a:t>
+            </a:r>
+          </a:p>
+          <a:p>
+            <a:pPr lvl="1">
+              <a:spcBef>
+                <a:spcPts val="600"/>
+              </a:spcBef>
+              <a:spcAft>
+                <a:spcPts val="200"/>
+              </a:spcAft>
+              <a:defRPr sz="1400" b="0">
+                <a:solidFill>
+                  <a:srgbClr val="A6E3A1"/>
+                </a:solidFill>
+              </a:defRPr>
+            </a:pPr>
+            <a:r>
+              <a:t>$ ai-review --model codellama</a:t>
+            </a:r>
+          </a:p>
+          <a:p>
+            <a:pPr lvl="1">
+              <a:spcBef>
+                <a:spcPts val="600"/>
+              </a:spcBef>
+              <a:spcAft>
+                <a:spcPts val="200"/>
+              </a:spcAft>
+              <a:defRPr sz="1400" b="0">
+                <a:solidFill>
+                  <a:srgbClr val="A6E3A1"/>
+                </a:solidFill>
+              </a:defRPr>
+            </a:pPr>
+            <a:r>
+              <a:t>$ ai-review --provider openai --model gpt-4o</a:t>
+            </a:r>
+          </a:p>
+        </p:txBody>
+      </p:sp>
+      <p:sp>
+        <p:nvSpPr>
+          <p:cNvPr id="5" name="TextBox 4"/>
+          <p:cNvSpPr txBox="1"/>
+          <p:nvPr/>
+        </p:nvSpPr>
+        <p:spPr>
+          <a:xfrm>
+            <a:off x="457200" y="6217920"/>
+            <a:ext cx="10972800" cy="457200"/>
+          </a:xfrm>
+          <a:prstGeom prst="rect">
+            <a:avLst/>
+          </a:prstGeom>
+          <a:noFill/>
+        </p:spPr>
+        <p:txBody>
+          <a:bodyPr wrap="square">
+            <a:spAutoFit/>
+          </a:bodyPr>
+          <a:lstStyle/>
+          <a:p>
+            <a:pPr algn="l">
+              <a:defRPr sz="1200" b="0">
+                <a:solidFill>
+                  <a:srgbClr val="6C7086"/>
+                </a:solidFill>
+              </a:defRPr>
+            </a:pPr>
+            <a:r>
+              <a:t>小模型（3B）速度快但可能誤報 ｜ 大模型（7B+）品質好但較慢</a:t>
+            </a:r>
+          </a:p>
+        </p:txBody>
+      </p:sp>
+    </p:spTree>
+  </p:cSld>
+  <p:clrMapOvr>
+    <a:masterClrMapping/>
+  </p:clrMapOvr>
+</p:sld>
+</file>
+
+<file path=ppt/slides/slide27.xml><?xml version="1.0" encoding="utf-8"?>
+<p:sld xmlns:a="http://schemas.openxmlformats.org/drawingml/2006/main" xmlns:p="http://schemas.openxmlformats.org/presentationml/2006/main" xmlns:r="http://schemas.openxmlformats.org/officeDocument/2006/relationships">
+  <p:cSld>
+    <p:bg>
+      <p:bgPr>
+        <a:solidFill>
+          <a:srgbClr val="1E1E2E"/>
+        </a:solidFill>
+        <a:effectLst/>
+      </p:bgPr>
+    </p:bg>
+    <p:spTree>
+      <p:nvGrpSpPr>
+        <p:cNvPr id="1" name=""/>
+        <p:cNvGrpSpPr/>
+        <p:nvPr/>
+      </p:nvGrpSpPr>
+      <p:grpSpPr/>
+      <p:sp>
+        <p:nvSpPr>
+          <p:cNvPr id="2" name="TextBox 1"/>
+          <p:cNvSpPr txBox="1"/>
+          <p:nvPr/>
+        </p:nvSpPr>
+        <p:spPr>
+          <a:xfrm>
+            <a:off x="457200" y="274320"/>
+            <a:ext cx="10972800" cy="640080"/>
+          </a:xfrm>
+          <a:prstGeom prst="rect">
+            <a:avLst/>
+          </a:prstGeom>
+          <a:noFill/>
+        </p:spPr>
+        <p:txBody>
+          <a:bodyPr wrap="square">
+            <a:spAutoFit/>
+          </a:bodyPr>
+          <a:lstStyle/>
+          <a:p>
+            <a:pPr algn="l">
+              <a:defRPr sz="2800" b="1">
+                <a:solidFill>
+                  <a:srgbClr val="89B4FA"/>
+                </a:solidFill>
+              </a:defRPr>
+            </a:pPr>
+            <a:r>
+              <a:t>9. 模型比較</a:t>
             </a:r>
           </a:p>
         </p:txBody>
@@ -7691,7 +9211,7 @@
 </p:sld>
 </file>
 
-<file path=ppt/slides/slide24.xml><?xml version="1.0" encoding="utf-8"?>
+<file path=ppt/slides/slide28.xml><?xml version="1.0" encoding="utf-8"?>
 <p:sld xmlns:a="http://schemas.openxmlformats.org/drawingml/2006/main" xmlns:p="http://schemas.openxmlformats.org/presentationml/2006/main" xmlns:r="http://schemas.openxmlformats.org/officeDocument/2006/relationships">
   <p:cSld>
     <p:bg>
@@ -7739,7 +9259,7 @@
               </a:defRPr>
             </a:pPr>
             <a:r>
-              <a:t>8. 遠端 Ollama Server 架構</a:t>
+              <a:t>9. 遠端 Ollama Server 架構</a:t>
             </a:r>
           </a:p>
         </p:txBody>
@@ -8057,7 +9577,7 @@
 </p:sld>
 </file>
 
-<file path=ppt/slides/slide25.xml><?xml version="1.0" encoding="utf-8"?>
+<file path=ppt/slides/slide29.xml><?xml version="1.0" encoding="utf-8"?>
 <p:sld xmlns:a="http://schemas.openxmlformats.org/drawingml/2006/main" xmlns:p="http://schemas.openxmlformats.org/presentationml/2006/main" xmlns:r="http://schemas.openxmlformats.org/officeDocument/2006/relationships">
   <p:cSld>
     <p:bg>
@@ -8105,7 +9625,7 @@
               </a:defRPr>
             </a:pPr>
             <a:r>
-              <a:t>8. Server 端設定 — 讓 Ollama 監聽所有網卡</a:t>
+              <a:t>9. Server 端設定 — 讓 Ollama 監聽所有網卡</a:t>
             </a:r>
           </a:p>
         </p:txBody>
@@ -9104,7 +10624,450 @@
 </p:sld>
 </file>
 
-<file path=ppt/slides/slide26.xml><?xml version="1.0" encoding="utf-8"?>
+<file path=ppt/slides/slide3.xml><?xml version="1.0" encoding="utf-8"?>
+<p:sld xmlns:a="http://schemas.openxmlformats.org/drawingml/2006/main" xmlns:p="http://schemas.openxmlformats.org/presentationml/2006/main" xmlns:r="http://schemas.openxmlformats.org/officeDocument/2006/relationships">
+  <p:cSld>
+    <p:bg>
+      <p:bgPr>
+        <a:solidFill>
+          <a:srgbClr val="1E1E2E"/>
+        </a:solidFill>
+        <a:effectLst/>
+      </p:bgPr>
+    </p:bg>
+    <p:spTree>
+      <p:nvGrpSpPr>
+        <p:cNvPr id="1" name=""/>
+        <p:cNvGrpSpPr/>
+        <p:nvPr/>
+      </p:nvGrpSpPr>
+      <p:grpSpPr/>
+      <p:sp>
+        <p:nvSpPr>
+          <p:cNvPr id="2" name="TextBox 1"/>
+          <p:cNvSpPr txBox="1"/>
+          <p:nvPr/>
+        </p:nvSpPr>
+        <p:spPr>
+          <a:xfrm>
+            <a:off x="457200" y="274320"/>
+            <a:ext cx="10972800" cy="640080"/>
+          </a:xfrm>
+          <a:prstGeom prst="rect">
+            <a:avLst/>
+          </a:prstGeom>
+          <a:noFill/>
+        </p:spPr>
+        <p:txBody>
+          <a:bodyPr wrap="square">
+            <a:spAutoFit/>
+          </a:bodyPr>
+          <a:lstStyle/>
+          <a:p>
+            <a:pPr algn="l">
+              <a:defRPr sz="2800" b="1">
+                <a:solidFill>
+                  <a:srgbClr val="89B4FA"/>
+                </a:solidFill>
+              </a:defRPr>
+            </a:pPr>
+            <a:r>
+              <a:t>1. 環境需求</a:t>
+            </a:r>
+          </a:p>
+        </p:txBody>
+      </p:sp>
+      <p:graphicFrame>
+        <p:nvGraphicFramePr>
+          <p:cNvPr id="3" name="Table 2"/>
+          <p:cNvGraphicFramePr>
+            <a:graphicFrameLocks noGrp="1"/>
+          </p:cNvGraphicFramePr>
+          <p:nvPr/>
+        </p:nvGraphicFramePr>
+        <p:xfrm>
+          <a:off x="594360" y="1097280"/>
+          <a:ext cx="10972800" cy="2743200"/>
+        </p:xfrm>
+        <a:graphic>
+          <a:graphicData uri="http://schemas.openxmlformats.org/drawingml/2006/table">
+            <a:tbl>
+              <a:tblPr firstRow="1" bandRow="1">
+                <a:tableStyleId>{5C22544A-7EE6-4342-B048-85BDC9FD1C3A}</a:tableStyleId>
+              </a:tblPr>
+              <a:tblGrid>
+                <a:gridCol w="3657600"/>
+                <a:gridCol w="3657600"/>
+                <a:gridCol w="3657600"/>
+              </a:tblGrid>
+              <a:tr h="548640">
+                <a:tc>
+                  <a:txBody>
+                    <a:bodyPr/>
+                    <a:lstStyle/>
+                    <a:p>
+                      <a:pPr>
+                        <a:defRPr sz="1400" b="1">
+                          <a:solidFill>
+                            <a:srgbClr val="1E1E2E"/>
+                          </a:solidFill>
+                        </a:defRPr>
+                      </a:pPr>
+                      <a:r>
+                        <a:t>項目</a:t>
+                      </a:r>
+                    </a:p>
+                  </a:txBody>
+                  <a:tcPr>
+                    <a:solidFill>
+                      <a:srgbClr val="89B4FA"/>
+                    </a:solidFill>
+                  </a:tcPr>
+                </a:tc>
+                <a:tc>
+                  <a:txBody>
+                    <a:bodyPr/>
+                    <a:lstStyle/>
+                    <a:p>
+                      <a:pPr>
+                        <a:defRPr sz="1400" b="1">
+                          <a:solidFill>
+                            <a:srgbClr val="1E1E2E"/>
+                          </a:solidFill>
+                        </a:defRPr>
+                      </a:pPr>
+                      <a:r>
+                        <a:t>版本</a:t>
+                      </a:r>
+                    </a:p>
+                  </a:txBody>
+                  <a:tcPr>
+                    <a:solidFill>
+                      <a:srgbClr val="89B4FA"/>
+                    </a:solidFill>
+                  </a:tcPr>
+                </a:tc>
+                <a:tc>
+                  <a:txBody>
+                    <a:bodyPr/>
+                    <a:lstStyle/>
+                    <a:p>
+                      <a:pPr>
+                        <a:defRPr sz="1400" b="1">
+                          <a:solidFill>
+                            <a:srgbClr val="1E1E2E"/>
+                          </a:solidFill>
+                        </a:defRPr>
+                      </a:pPr>
+                      <a:r>
+                        <a:t>說明</a:t>
+                      </a:r>
+                    </a:p>
+                  </a:txBody>
+                  <a:tcPr>
+                    <a:solidFill>
+                      <a:srgbClr val="89B4FA"/>
+                    </a:solidFill>
+                  </a:tcPr>
+                </a:tc>
+              </a:tr>
+              <a:tr h="548640">
+                <a:tc>
+                  <a:txBody>
+                    <a:bodyPr/>
+                    <a:lstStyle/>
+                    <a:p>
+                      <a:pPr>
+                        <a:defRPr sz="1300">
+                          <a:solidFill>
+                            <a:srgbClr val="CDD6F4"/>
+                          </a:solidFill>
+                        </a:defRPr>
+                      </a:pPr>
+                      <a:r>
+                        <a:t>Python</a:t>
+                      </a:r>
+                    </a:p>
+                  </a:txBody>
+                  <a:tcPr>
+                    <a:solidFill>
+                      <a:srgbClr val="31344B"/>
+                    </a:solidFill>
+                  </a:tcPr>
+                </a:tc>
+                <a:tc>
+                  <a:txBody>
+                    <a:bodyPr/>
+                    <a:lstStyle/>
+                    <a:p>
+                      <a:pPr>
+                        <a:defRPr sz="1300">
+                          <a:solidFill>
+                            <a:srgbClr val="CDD6F4"/>
+                          </a:solidFill>
+                        </a:defRPr>
+                      </a:pPr>
+                      <a:r>
+                        <a:t>&gt;= 3.10</a:t>
+                      </a:r>
+                    </a:p>
+                  </a:txBody>
+                  <a:tcPr>
+                    <a:solidFill>
+                      <a:srgbClr val="31344B"/>
+                    </a:solidFill>
+                  </a:tcPr>
+                </a:tc>
+                <a:tc>
+                  <a:txBody>
+                    <a:bodyPr/>
+                    <a:lstStyle/>
+                    <a:p>
+                      <a:pPr>
+                        <a:defRPr sz="1300">
+                          <a:solidFill>
+                            <a:srgbClr val="CDD6F4"/>
+                          </a:solidFill>
+                        </a:defRPr>
+                      </a:pPr>
+                      <a:r>
+                        <a:t>核心執行環境</a:t>
+                      </a:r>
+                    </a:p>
+                  </a:txBody>
+                  <a:tcPr>
+                    <a:solidFill>
+                      <a:srgbClr val="31344B"/>
+                    </a:solidFill>
+                  </a:tcPr>
+                </a:tc>
+              </a:tr>
+              <a:tr h="548640">
+                <a:tc>
+                  <a:txBody>
+                    <a:bodyPr/>
+                    <a:lstStyle/>
+                    <a:p>
+                      <a:pPr>
+                        <a:defRPr sz="1300">
+                          <a:solidFill>
+                            <a:srgbClr val="CDD6F4"/>
+                          </a:solidFill>
+                        </a:defRPr>
+                      </a:pPr>
+                      <a:r>
+                        <a:t>Git</a:t>
+                      </a:r>
+                    </a:p>
+                  </a:txBody>
+                  <a:tcPr>
+                    <a:solidFill>
+                      <a:srgbClr val="24273A"/>
+                    </a:solidFill>
+                  </a:tcPr>
+                </a:tc>
+                <a:tc>
+                  <a:txBody>
+                    <a:bodyPr/>
+                    <a:lstStyle/>
+                    <a:p>
+                      <a:pPr>
+                        <a:defRPr sz="1300">
+                          <a:solidFill>
+                            <a:srgbClr val="CDD6F4"/>
+                          </a:solidFill>
+                        </a:defRPr>
+                      </a:pPr>
+                      <a:r>
+                        <a:t>任意版本</a:t>
+                      </a:r>
+                    </a:p>
+                  </a:txBody>
+                  <a:tcPr>
+                    <a:solidFill>
+                      <a:srgbClr val="24273A"/>
+                    </a:solidFill>
+                  </a:tcPr>
+                </a:tc>
+                <a:tc>
+                  <a:txBody>
+                    <a:bodyPr/>
+                    <a:lstStyle/>
+                    <a:p>
+                      <a:pPr>
+                        <a:defRPr sz="1300">
+                          <a:solidFill>
+                            <a:srgbClr val="CDD6F4"/>
+                          </a:solidFill>
+                        </a:defRPr>
+                      </a:pPr>
+                      <a:r>
+                        <a:t>版本管理 + hooks</a:t>
+                      </a:r>
+                    </a:p>
+                  </a:txBody>
+                  <a:tcPr>
+                    <a:solidFill>
+                      <a:srgbClr val="24273A"/>
+                    </a:solidFill>
+                  </a:tcPr>
+                </a:tc>
+              </a:tr>
+              <a:tr h="548640">
+                <a:tc>
+                  <a:txBody>
+                    <a:bodyPr/>
+                    <a:lstStyle/>
+                    <a:p>
+                      <a:pPr>
+                        <a:defRPr sz="1300">
+                          <a:solidFill>
+                            <a:srgbClr val="CDD6F4"/>
+                          </a:solidFill>
+                        </a:defRPr>
+                      </a:pPr>
+                      <a:r>
+                        <a:t>pip</a:t>
+                      </a:r>
+                    </a:p>
+                  </a:txBody>
+                  <a:tcPr>
+                    <a:solidFill>
+                      <a:srgbClr val="31344B"/>
+                    </a:solidFill>
+                  </a:tcPr>
+                </a:tc>
+                <a:tc>
+                  <a:txBody>
+                    <a:bodyPr/>
+                    <a:lstStyle/>
+                    <a:p>
+                      <a:pPr>
+                        <a:defRPr sz="1300">
+                          <a:solidFill>
+                            <a:srgbClr val="CDD6F4"/>
+                          </a:solidFill>
+                        </a:defRPr>
+                      </a:pPr>
+                      <a:r>
+                        <a:t>任意版本</a:t>
+                      </a:r>
+                    </a:p>
+                  </a:txBody>
+                  <a:tcPr>
+                    <a:solidFill>
+                      <a:srgbClr val="31344B"/>
+                    </a:solidFill>
+                  </a:tcPr>
+                </a:tc>
+                <a:tc>
+                  <a:txBody>
+                    <a:bodyPr/>
+                    <a:lstStyle/>
+                    <a:p>
+                      <a:pPr>
+                        <a:defRPr sz="1300">
+                          <a:solidFill>
+                            <a:srgbClr val="CDD6F4"/>
+                          </a:solidFill>
+                        </a:defRPr>
+                      </a:pPr>
+                      <a:r>
+                        <a:t>Python 套件管理</a:t>
+                      </a:r>
+                    </a:p>
+                  </a:txBody>
+                  <a:tcPr>
+                    <a:solidFill>
+                      <a:srgbClr val="31344B"/>
+                    </a:solidFill>
+                  </a:tcPr>
+                </a:tc>
+              </a:tr>
+              <a:tr h="548640">
+                <a:tc>
+                  <a:txBody>
+                    <a:bodyPr/>
+                    <a:lstStyle/>
+                    <a:p>
+                      <a:pPr>
+                        <a:defRPr sz="1300">
+                          <a:solidFill>
+                            <a:srgbClr val="CDD6F4"/>
+                          </a:solidFill>
+                        </a:defRPr>
+                      </a:pPr>
+                      <a:r>
+                        <a:t>Ollama（選用）</a:t>
+                      </a:r>
+                    </a:p>
+                  </a:txBody>
+                  <a:tcPr>
+                    <a:solidFill>
+                      <a:srgbClr val="24273A"/>
+                    </a:solidFill>
+                  </a:tcPr>
+                </a:tc>
+                <a:tc>
+                  <a:txBody>
+                    <a:bodyPr/>
+                    <a:lstStyle/>
+                    <a:p>
+                      <a:pPr>
+                        <a:defRPr sz="1300">
+                          <a:solidFill>
+                            <a:srgbClr val="CDD6F4"/>
+                          </a:solidFill>
+                        </a:defRPr>
+                      </a:pPr>
+                      <a:r>
+                        <a:t>任意版本</a:t>
+                      </a:r>
+                    </a:p>
+                  </a:txBody>
+                  <a:tcPr>
+                    <a:solidFill>
+                      <a:srgbClr val="24273A"/>
+                    </a:solidFill>
+                  </a:tcPr>
+                </a:tc>
+                <a:tc>
+                  <a:txBody>
+                    <a:bodyPr/>
+                    <a:lstStyle/>
+                    <a:p>
+                      <a:pPr>
+                        <a:defRPr sz="1300">
+                          <a:solidFill>
+                            <a:srgbClr val="CDD6F4"/>
+                          </a:solidFill>
+                        </a:defRPr>
+                      </a:pPr>
+                      <a:r>
+                        <a:t>本地 LLM 推理引擎</a:t>
+                      </a:r>
+                    </a:p>
+                  </a:txBody>
+                  <a:tcPr>
+                    <a:solidFill>
+                      <a:srgbClr val="24273A"/>
+                    </a:solidFill>
+                  </a:tcPr>
+                </a:tc>
+              </a:tr>
+            </a:tbl>
+          </a:graphicData>
+        </a:graphic>
+      </p:graphicFrame>
+    </p:spTree>
+  </p:cSld>
+  <p:clrMapOvr>
+    <a:masterClrMapping/>
+  </p:clrMapOvr>
+</p:sld>
+</file>
+
+<file path=ppt/slides/slide30.xml><?xml version="1.0" encoding="utf-8"?>
 <p:sld xmlns:a="http://schemas.openxmlformats.org/drawingml/2006/main" xmlns:p="http://schemas.openxmlformats.org/presentationml/2006/main" xmlns:r="http://schemas.openxmlformats.org/officeDocument/2006/relationships">
   <p:cSld>
     <p:bg>
@@ -9169,7 +11132,7 @@
               </a:defRPr>
             </a:pPr>
             <a:r>
-              <a:t>9</a:t>
+              <a:t>10</a:t>
             </a:r>
           </a:p>
         </p:txBody>
@@ -9217,7 +11180,7 @@
 </p:sld>
 </file>
 
-<file path=ppt/slides/slide27.xml><?xml version="1.0" encoding="utf-8"?>
+<file path=ppt/slides/slide31.xml><?xml version="1.0" encoding="utf-8"?>
 <p:sld xmlns:a="http://schemas.openxmlformats.org/drawingml/2006/main" xmlns:p="http://schemas.openxmlformats.org/presentationml/2006/main" xmlns:r="http://schemas.openxmlformats.org/officeDocument/2006/relationships">
   <p:cSld>
     <p:bg>
@@ -9265,7 +11228,7 @@
               </a:defRPr>
             </a:pPr>
             <a:r>
-              <a:t>9. 設定與診斷指令</a:t>
+              <a:t>10. 設定與診斷指令</a:t>
             </a:r>
           </a:p>
         </p:txBody>
@@ -9736,7 +11699,7 @@
 </p:sld>
 </file>
 
-<file path=ppt/slides/slide28.xml><?xml version="1.0" encoding="utf-8"?>
+<file path=ppt/slides/slide32.xml><?xml version="1.0" encoding="utf-8"?>
 <p:sld xmlns:a="http://schemas.openxmlformats.org/drawingml/2006/main" xmlns:p="http://schemas.openxmlformats.org/presentationml/2006/main" xmlns:r="http://schemas.openxmlformats.org/officeDocument/2006/relationships">
   <p:cSld>
     <p:bg>
@@ -9784,7 +11747,7 @@
               </a:defRPr>
             </a:pPr>
             <a:r>
-              <a:t>9. Hook 管理指令</a:t>
+              <a:t>10. Hook 管理指令</a:t>
             </a:r>
           </a:p>
         </p:txBody>
@@ -9799,7 +11762,7 @@
         </p:nvGraphicFramePr>
         <p:xfrm>
           <a:off x="594360" y="1097280"/>
-          <a:ext cx="10972800" cy="4114800"/>
+          <a:ext cx="10972800" cy="5029200"/>
         </p:xfrm>
         <a:graphic>
           <a:graphicData uri="http://schemas.openxmlformats.org/drawingml/2006/table">
@@ -9811,7 +11774,7 @@
                 <a:gridCol w="5486400"/>
                 <a:gridCol w="5486400"/>
               </a:tblGrid>
-              <a:tr h="514350">
+              <a:tr h="502920">
                 <a:tc>
                   <a:txBody>
                     <a:bodyPr/>
@@ -9859,7 +11822,7 @@
                   </a:tcPr>
                 </a:tc>
               </a:tr>
-              <a:tr h="514350">
+              <a:tr h="502920">
                 <a:tc>
                   <a:txBody>
                     <a:bodyPr/>
@@ -9907,7 +11870,7 @@
                   </a:tcPr>
                 </a:tc>
               </a:tr>
-              <a:tr h="514350">
+              <a:tr h="502920">
                 <a:tc>
                   <a:txBody>
                     <a:bodyPr/>
@@ -9955,7 +11918,7 @@
                   </a:tcPr>
                 </a:tc>
               </a:tr>
-              <a:tr h="514350">
+              <a:tr h="502920">
                 <a:tc>
                   <a:txBody>
                     <a:bodyPr/>
@@ -9969,7 +11932,7 @@
                         </a:defRPr>
                       </a:pPr>
                       <a:r>
-                        <a:t>ai-review hook install &lt;hook_type&gt;</a:t>
+                        <a:t>ai-review hook uninstall --template</a:t>
                       </a:r>
                     </a:p>
                   </a:txBody>
@@ -9992,7 +11955,7 @@
                         </a:defRPr>
                       </a:pPr>
                       <a:r>
-                        <a:t>安裝單一 repo hook</a:t>
+                        <a:t>移除 template hooks</a:t>
                       </a:r>
                     </a:p>
                   </a:txBody>
@@ -10003,7 +11966,7 @@
                   </a:tcPr>
                 </a:tc>
               </a:tr>
-              <a:tr h="514350">
+              <a:tr h="502920">
                 <a:tc>
                   <a:txBody>
                     <a:bodyPr/>
@@ -10017,7 +11980,7 @@
                         </a:defRPr>
                       </a:pPr>
                       <a:r>
-                        <a:t>ai-review hook uninstall --template</a:t>
+                        <a:t>ai-review hook status</a:t>
                       </a:r>
                     </a:p>
                   </a:txBody>
@@ -10040,7 +12003,7 @@
                         </a:defRPr>
                       </a:pPr>
                       <a:r>
-                        <a:t>移除 template hooks</a:t>
+                        <a:t>查看 hook 安裝狀態</a:t>
                       </a:r>
                     </a:p>
                   </a:txBody>
@@ -10051,7 +12014,7 @@
                   </a:tcPr>
                 </a:tc>
               </a:tr>
-              <a:tr h="514350">
+              <a:tr h="502920">
                 <a:tc>
                   <a:txBody>
                     <a:bodyPr/>
@@ -10065,7 +12028,7 @@
                         </a:defRPr>
                       </a:pPr>
                       <a:r>
-                        <a:t>ai-review hook status</a:t>
+                        <a:t>ai-review hook enable</a:t>
                       </a:r>
                     </a:p>
                   </a:txBody>
@@ -10088,7 +12051,7 @@
                         </a:defRPr>
                       </a:pPr>
                       <a:r>
-                        <a:t>查看 hook 安裝狀態</a:t>
+                        <a:t>啟用當前 repo（自動安裝 hooks）</a:t>
                       </a:r>
                     </a:p>
                   </a:txBody>
@@ -10099,7 +12062,7 @@
                   </a:tcPr>
                 </a:tc>
               </a:tr>
-              <a:tr h="514350">
+              <a:tr h="502920">
                 <a:tc>
                   <a:txBody>
                     <a:bodyPr/>
@@ -10113,7 +12076,7 @@
                         </a:defRPr>
                       </a:pPr>
                       <a:r>
-                        <a:t>ai-review hook enable</a:t>
+                        <a:t>hook enable --path &lt;dir&gt;</a:t>
                       </a:r>
                     </a:p>
                   </a:txBody>
@@ -10136,7 +12099,7 @@
                         </a:defRPr>
                       </a:pPr>
                       <a:r>
-                        <a:t>啟用當前 repo</a:t>
+                        <a:t>啟用指定 repo（可重複）</a:t>
                       </a:r>
                     </a:p>
                   </a:txBody>
@@ -10147,7 +12110,7 @@
                   </a:tcPr>
                 </a:tc>
               </a:tr>
-              <a:tr h="514350">
+              <a:tr h="502920">
                 <a:tc>
                   <a:txBody>
                     <a:bodyPr/>
@@ -10161,7 +12124,7 @@
                         </a:defRPr>
                       </a:pPr>
                       <a:r>
-                        <a:t>ai-review hook disable</a:t>
+                        <a:t>hook enable --all &lt;dir&gt;</a:t>
                       </a:r>
                     </a:p>
                   </a:txBody>
@@ -10184,7 +12147,103 @@
                         </a:defRPr>
                       </a:pPr>
                       <a:r>
-                        <a:t>停用當前 repo</a:t>
+                        <a:t>批量啟用目錄下所有 repo</a:t>
+                      </a:r>
+                    </a:p>
+                  </a:txBody>
+                  <a:tcPr>
+                    <a:solidFill>
+                      <a:srgbClr val="31344B"/>
+                    </a:solidFill>
+                  </a:tcPr>
+                </a:tc>
+              </a:tr>
+              <a:tr h="502920">
+                <a:tc>
+                  <a:txBody>
+                    <a:bodyPr/>
+                    <a:lstStyle/>
+                    <a:p>
+                      <a:pPr>
+                        <a:defRPr sz="1300">
+                          <a:solidFill>
+                            <a:srgbClr val="CDD6F4"/>
+                          </a:solidFill>
+                        </a:defRPr>
+                      </a:pPr>
+                      <a:r>
+                        <a:t>hook enable --all &lt;dir&gt; --list</a:t>
+                      </a:r>
+                    </a:p>
+                  </a:txBody>
+                  <a:tcPr>
+                    <a:solidFill>
+                      <a:srgbClr val="24273A"/>
+                    </a:solidFill>
+                  </a:tcPr>
+                </a:tc>
+                <a:tc>
+                  <a:txBody>
+                    <a:bodyPr/>
+                    <a:lstStyle/>
+                    <a:p>
+                      <a:pPr>
+                        <a:defRPr sz="1300">
+                          <a:solidFill>
+                            <a:srgbClr val="CDD6F4"/>
+                          </a:solidFill>
+                        </a:defRPr>
+                      </a:pPr>
+                      <a:r>
+                        <a:t>預覽所有 repo 狀態</a:t>
+                      </a:r>
+                    </a:p>
+                  </a:txBody>
+                  <a:tcPr>
+                    <a:solidFill>
+                      <a:srgbClr val="24273A"/>
+                    </a:solidFill>
+                  </a:tcPr>
+                </a:tc>
+              </a:tr>
+              <a:tr h="502920">
+                <a:tc>
+                  <a:txBody>
+                    <a:bodyPr/>
+                    <a:lstStyle/>
+                    <a:p>
+                      <a:pPr>
+                        <a:defRPr sz="1300">
+                          <a:solidFill>
+                            <a:srgbClr val="CDD6F4"/>
+                          </a:solidFill>
+                        </a:defRPr>
+                      </a:pPr>
+                      <a:r>
+                        <a:t>hook disable --all &lt;dir&gt;</a:t>
+                      </a:r>
+                    </a:p>
+                  </a:txBody>
+                  <a:tcPr>
+                    <a:solidFill>
+                      <a:srgbClr val="31344B"/>
+                    </a:solidFill>
+                  </a:tcPr>
+                </a:tc>
+                <a:tc>
+                  <a:txBody>
+                    <a:bodyPr/>
+                    <a:lstStyle/>
+                    <a:p>
+                      <a:pPr>
+                        <a:defRPr sz="1300">
+                          <a:solidFill>
+                            <a:srgbClr val="CDD6F4"/>
+                          </a:solidFill>
+                        </a:defRPr>
+                      </a:pPr>
+                      <a:r>
+                        <a:t>批量停用</a:t>
                       </a:r>
                     </a:p>
                   </a:txBody>
@@ -10207,7 +12266,7 @@
 </p:sld>
 </file>
 
-<file path=ppt/slides/slide29.xml><?xml version="1.0" encoding="utf-8"?>
+<file path=ppt/slides/slide33.xml><?xml version="1.0" encoding="utf-8"?>
 <p:sld xmlns:a="http://schemas.openxmlformats.org/drawingml/2006/main" xmlns:p="http://schemas.openxmlformats.org/presentationml/2006/main" xmlns:r="http://schemas.openxmlformats.org/officeDocument/2006/relationships">
   <p:cSld>
     <p:bg>
@@ -10272,7 +12331,7 @@
               </a:defRPr>
             </a:pPr>
             <a:r>
-              <a:t>10</a:t>
+              <a:t>11</a:t>
             </a:r>
           </a:p>
         </p:txBody>
@@ -10320,7 +12379,7 @@
 </p:sld>
 </file>
 
-<file path=ppt/slides/slide3.xml><?xml version="1.0" encoding="utf-8"?>
+<file path=ppt/slides/slide34.xml><?xml version="1.0" encoding="utf-8"?>
 <p:sld xmlns:a="http://schemas.openxmlformats.org/drawingml/2006/main" xmlns:p="http://schemas.openxmlformats.org/presentationml/2006/main" xmlns:r="http://schemas.openxmlformats.org/officeDocument/2006/relationships">
   <p:cSld>
     <p:bg>
@@ -10368,450 +12427,7 @@
               </a:defRPr>
             </a:pPr>
             <a:r>
-              <a:t>1. 環境需求</a:t>
-            </a:r>
-          </a:p>
-        </p:txBody>
-      </p:sp>
-      <p:graphicFrame>
-        <p:nvGraphicFramePr>
-          <p:cNvPr id="3" name="Table 2"/>
-          <p:cNvGraphicFramePr>
-            <a:graphicFrameLocks noGrp="1"/>
-          </p:cNvGraphicFramePr>
-          <p:nvPr/>
-        </p:nvGraphicFramePr>
-        <p:xfrm>
-          <a:off x="594360" y="1097280"/>
-          <a:ext cx="10972800" cy="2743200"/>
-        </p:xfrm>
-        <a:graphic>
-          <a:graphicData uri="http://schemas.openxmlformats.org/drawingml/2006/table">
-            <a:tbl>
-              <a:tblPr firstRow="1" bandRow="1">
-                <a:tableStyleId>{5C22544A-7EE6-4342-B048-85BDC9FD1C3A}</a:tableStyleId>
-              </a:tblPr>
-              <a:tblGrid>
-                <a:gridCol w="3657600"/>
-                <a:gridCol w="3657600"/>
-                <a:gridCol w="3657600"/>
-              </a:tblGrid>
-              <a:tr h="548640">
-                <a:tc>
-                  <a:txBody>
-                    <a:bodyPr/>
-                    <a:lstStyle/>
-                    <a:p>
-                      <a:pPr>
-                        <a:defRPr sz="1400" b="1">
-                          <a:solidFill>
-                            <a:srgbClr val="1E1E2E"/>
-                          </a:solidFill>
-                        </a:defRPr>
-                      </a:pPr>
-                      <a:r>
-                        <a:t>項目</a:t>
-                      </a:r>
-                    </a:p>
-                  </a:txBody>
-                  <a:tcPr>
-                    <a:solidFill>
-                      <a:srgbClr val="89B4FA"/>
-                    </a:solidFill>
-                  </a:tcPr>
-                </a:tc>
-                <a:tc>
-                  <a:txBody>
-                    <a:bodyPr/>
-                    <a:lstStyle/>
-                    <a:p>
-                      <a:pPr>
-                        <a:defRPr sz="1400" b="1">
-                          <a:solidFill>
-                            <a:srgbClr val="1E1E2E"/>
-                          </a:solidFill>
-                        </a:defRPr>
-                      </a:pPr>
-                      <a:r>
-                        <a:t>版本</a:t>
-                      </a:r>
-                    </a:p>
-                  </a:txBody>
-                  <a:tcPr>
-                    <a:solidFill>
-                      <a:srgbClr val="89B4FA"/>
-                    </a:solidFill>
-                  </a:tcPr>
-                </a:tc>
-                <a:tc>
-                  <a:txBody>
-                    <a:bodyPr/>
-                    <a:lstStyle/>
-                    <a:p>
-                      <a:pPr>
-                        <a:defRPr sz="1400" b="1">
-                          <a:solidFill>
-                            <a:srgbClr val="1E1E2E"/>
-                          </a:solidFill>
-                        </a:defRPr>
-                      </a:pPr>
-                      <a:r>
-                        <a:t>說明</a:t>
-                      </a:r>
-                    </a:p>
-                  </a:txBody>
-                  <a:tcPr>
-                    <a:solidFill>
-                      <a:srgbClr val="89B4FA"/>
-                    </a:solidFill>
-                  </a:tcPr>
-                </a:tc>
-              </a:tr>
-              <a:tr h="548640">
-                <a:tc>
-                  <a:txBody>
-                    <a:bodyPr/>
-                    <a:lstStyle/>
-                    <a:p>
-                      <a:pPr>
-                        <a:defRPr sz="1300">
-                          <a:solidFill>
-                            <a:srgbClr val="CDD6F4"/>
-                          </a:solidFill>
-                        </a:defRPr>
-                      </a:pPr>
-                      <a:r>
-                        <a:t>Python</a:t>
-                      </a:r>
-                    </a:p>
-                  </a:txBody>
-                  <a:tcPr>
-                    <a:solidFill>
-                      <a:srgbClr val="31344B"/>
-                    </a:solidFill>
-                  </a:tcPr>
-                </a:tc>
-                <a:tc>
-                  <a:txBody>
-                    <a:bodyPr/>
-                    <a:lstStyle/>
-                    <a:p>
-                      <a:pPr>
-                        <a:defRPr sz="1300">
-                          <a:solidFill>
-                            <a:srgbClr val="CDD6F4"/>
-                          </a:solidFill>
-                        </a:defRPr>
-                      </a:pPr>
-                      <a:r>
-                        <a:t>&gt;= 3.10</a:t>
-                      </a:r>
-                    </a:p>
-                  </a:txBody>
-                  <a:tcPr>
-                    <a:solidFill>
-                      <a:srgbClr val="31344B"/>
-                    </a:solidFill>
-                  </a:tcPr>
-                </a:tc>
-                <a:tc>
-                  <a:txBody>
-                    <a:bodyPr/>
-                    <a:lstStyle/>
-                    <a:p>
-                      <a:pPr>
-                        <a:defRPr sz="1300">
-                          <a:solidFill>
-                            <a:srgbClr val="CDD6F4"/>
-                          </a:solidFill>
-                        </a:defRPr>
-                      </a:pPr>
-                      <a:r>
-                        <a:t>核心執行環境</a:t>
-                      </a:r>
-                    </a:p>
-                  </a:txBody>
-                  <a:tcPr>
-                    <a:solidFill>
-                      <a:srgbClr val="31344B"/>
-                    </a:solidFill>
-                  </a:tcPr>
-                </a:tc>
-              </a:tr>
-              <a:tr h="548640">
-                <a:tc>
-                  <a:txBody>
-                    <a:bodyPr/>
-                    <a:lstStyle/>
-                    <a:p>
-                      <a:pPr>
-                        <a:defRPr sz="1300">
-                          <a:solidFill>
-                            <a:srgbClr val="CDD6F4"/>
-                          </a:solidFill>
-                        </a:defRPr>
-                      </a:pPr>
-                      <a:r>
-                        <a:t>Git</a:t>
-                      </a:r>
-                    </a:p>
-                  </a:txBody>
-                  <a:tcPr>
-                    <a:solidFill>
-                      <a:srgbClr val="24273A"/>
-                    </a:solidFill>
-                  </a:tcPr>
-                </a:tc>
-                <a:tc>
-                  <a:txBody>
-                    <a:bodyPr/>
-                    <a:lstStyle/>
-                    <a:p>
-                      <a:pPr>
-                        <a:defRPr sz="1300">
-                          <a:solidFill>
-                            <a:srgbClr val="CDD6F4"/>
-                          </a:solidFill>
-                        </a:defRPr>
-                      </a:pPr>
-                      <a:r>
-                        <a:t>任意版本</a:t>
-                      </a:r>
-                    </a:p>
-                  </a:txBody>
-                  <a:tcPr>
-                    <a:solidFill>
-                      <a:srgbClr val="24273A"/>
-                    </a:solidFill>
-                  </a:tcPr>
-                </a:tc>
-                <a:tc>
-                  <a:txBody>
-                    <a:bodyPr/>
-                    <a:lstStyle/>
-                    <a:p>
-                      <a:pPr>
-                        <a:defRPr sz="1300">
-                          <a:solidFill>
-                            <a:srgbClr val="CDD6F4"/>
-                          </a:solidFill>
-                        </a:defRPr>
-                      </a:pPr>
-                      <a:r>
-                        <a:t>版本管理 + hooks</a:t>
-                      </a:r>
-                    </a:p>
-                  </a:txBody>
-                  <a:tcPr>
-                    <a:solidFill>
-                      <a:srgbClr val="24273A"/>
-                    </a:solidFill>
-                  </a:tcPr>
-                </a:tc>
-              </a:tr>
-              <a:tr h="548640">
-                <a:tc>
-                  <a:txBody>
-                    <a:bodyPr/>
-                    <a:lstStyle/>
-                    <a:p>
-                      <a:pPr>
-                        <a:defRPr sz="1300">
-                          <a:solidFill>
-                            <a:srgbClr val="CDD6F4"/>
-                          </a:solidFill>
-                        </a:defRPr>
-                      </a:pPr>
-                      <a:r>
-                        <a:t>pip</a:t>
-                      </a:r>
-                    </a:p>
-                  </a:txBody>
-                  <a:tcPr>
-                    <a:solidFill>
-                      <a:srgbClr val="31344B"/>
-                    </a:solidFill>
-                  </a:tcPr>
-                </a:tc>
-                <a:tc>
-                  <a:txBody>
-                    <a:bodyPr/>
-                    <a:lstStyle/>
-                    <a:p>
-                      <a:pPr>
-                        <a:defRPr sz="1300">
-                          <a:solidFill>
-                            <a:srgbClr val="CDD6F4"/>
-                          </a:solidFill>
-                        </a:defRPr>
-                      </a:pPr>
-                      <a:r>
-                        <a:t>任意版本</a:t>
-                      </a:r>
-                    </a:p>
-                  </a:txBody>
-                  <a:tcPr>
-                    <a:solidFill>
-                      <a:srgbClr val="31344B"/>
-                    </a:solidFill>
-                  </a:tcPr>
-                </a:tc>
-                <a:tc>
-                  <a:txBody>
-                    <a:bodyPr/>
-                    <a:lstStyle/>
-                    <a:p>
-                      <a:pPr>
-                        <a:defRPr sz="1300">
-                          <a:solidFill>
-                            <a:srgbClr val="CDD6F4"/>
-                          </a:solidFill>
-                        </a:defRPr>
-                      </a:pPr>
-                      <a:r>
-                        <a:t>Python 套件管理</a:t>
-                      </a:r>
-                    </a:p>
-                  </a:txBody>
-                  <a:tcPr>
-                    <a:solidFill>
-                      <a:srgbClr val="31344B"/>
-                    </a:solidFill>
-                  </a:tcPr>
-                </a:tc>
-              </a:tr>
-              <a:tr h="548640">
-                <a:tc>
-                  <a:txBody>
-                    <a:bodyPr/>
-                    <a:lstStyle/>
-                    <a:p>
-                      <a:pPr>
-                        <a:defRPr sz="1300">
-                          <a:solidFill>
-                            <a:srgbClr val="CDD6F4"/>
-                          </a:solidFill>
-                        </a:defRPr>
-                      </a:pPr>
-                      <a:r>
-                        <a:t>Ollama（選用）</a:t>
-                      </a:r>
-                    </a:p>
-                  </a:txBody>
-                  <a:tcPr>
-                    <a:solidFill>
-                      <a:srgbClr val="24273A"/>
-                    </a:solidFill>
-                  </a:tcPr>
-                </a:tc>
-                <a:tc>
-                  <a:txBody>
-                    <a:bodyPr/>
-                    <a:lstStyle/>
-                    <a:p>
-                      <a:pPr>
-                        <a:defRPr sz="1300">
-                          <a:solidFill>
-                            <a:srgbClr val="CDD6F4"/>
-                          </a:solidFill>
-                        </a:defRPr>
-                      </a:pPr>
-                      <a:r>
-                        <a:t>任意版本</a:t>
-                      </a:r>
-                    </a:p>
-                  </a:txBody>
-                  <a:tcPr>
-                    <a:solidFill>
-                      <a:srgbClr val="24273A"/>
-                    </a:solidFill>
-                  </a:tcPr>
-                </a:tc>
-                <a:tc>
-                  <a:txBody>
-                    <a:bodyPr/>
-                    <a:lstStyle/>
-                    <a:p>
-                      <a:pPr>
-                        <a:defRPr sz="1300">
-                          <a:solidFill>
-                            <a:srgbClr val="CDD6F4"/>
-                          </a:solidFill>
-                        </a:defRPr>
-                      </a:pPr>
-                      <a:r>
-                        <a:t>本地 LLM 推理引擎</a:t>
-                      </a:r>
-                    </a:p>
-                  </a:txBody>
-                  <a:tcPr>
-                    <a:solidFill>
-                      <a:srgbClr val="24273A"/>
-                    </a:solidFill>
-                  </a:tcPr>
-                </a:tc>
-              </a:tr>
-            </a:tbl>
-          </a:graphicData>
-        </a:graphic>
-      </p:graphicFrame>
-    </p:spTree>
-  </p:cSld>
-  <p:clrMapOvr>
-    <a:masterClrMapping/>
-  </p:clrMapOvr>
-</p:sld>
-</file>
-
-<file path=ppt/slides/slide30.xml><?xml version="1.0" encoding="utf-8"?>
-<p:sld xmlns:a="http://schemas.openxmlformats.org/drawingml/2006/main" xmlns:p="http://schemas.openxmlformats.org/presentationml/2006/main" xmlns:r="http://schemas.openxmlformats.org/officeDocument/2006/relationships">
-  <p:cSld>
-    <p:bg>
-      <p:bgPr>
-        <a:solidFill>
-          <a:srgbClr val="1E1E2E"/>
-        </a:solidFill>
-        <a:effectLst/>
-      </p:bgPr>
-    </p:bg>
-    <p:spTree>
-      <p:nvGrpSpPr>
-        <p:cNvPr id="1" name=""/>
-        <p:cNvGrpSpPr/>
-        <p:nvPr/>
-      </p:nvGrpSpPr>
-      <p:grpSpPr/>
-      <p:sp>
-        <p:nvSpPr>
-          <p:cNvPr id="2" name="TextBox 1"/>
-          <p:cNvSpPr txBox="1"/>
-          <p:nvPr/>
-        </p:nvSpPr>
-        <p:spPr>
-          <a:xfrm>
-            <a:off x="457200" y="274320"/>
-            <a:ext cx="10972800" cy="640080"/>
-          </a:xfrm>
-          <a:prstGeom prst="rect">
-            <a:avLst/>
-          </a:prstGeom>
-          <a:noFill/>
-        </p:spPr>
-        <p:txBody>
-          <a:bodyPr wrap="square">
-            <a:spAutoFit/>
-          </a:bodyPr>
-          <a:lstStyle/>
-          <a:p>
-            <a:pPr algn="l">
-              <a:defRPr sz="2800" b="1">
-                <a:solidFill>
-                  <a:srgbClr val="89B4FA"/>
-                </a:solidFill>
-              </a:defRPr>
-            </a:pPr>
-            <a:r>
-              <a:t>10. 全平台通用問題</a:t>
+              <a:t>11. 全平台通用問題</a:t>
             </a:r>
           </a:p>
         </p:txBody>
@@ -11186,7 +12802,7 @@
 </p:sld>
 </file>
 
-<file path=ppt/slides/slide31.xml><?xml version="1.0" encoding="utf-8"?>
+<file path=ppt/slides/slide35.xml><?xml version="1.0" encoding="utf-8"?>
 <p:sld xmlns:a="http://schemas.openxmlformats.org/drawingml/2006/main" xmlns:p="http://schemas.openxmlformats.org/presentationml/2006/main" xmlns:r="http://schemas.openxmlformats.org/officeDocument/2006/relationships">
   <p:cSld>
     <p:bg>
@@ -11234,7 +12850,7 @@
               </a:defRPr>
             </a:pPr>
             <a:r>
-              <a:t>10. 平台專屬問題</a:t>
+              <a:t>11. 平台專屬問題</a:t>
             </a:r>
           </a:p>
         </p:txBody>
@@ -12024,7 +13640,7 @@
 </p:sld>
 </file>
 
-<file path=ppt/slides/slide32.xml><?xml version="1.0" encoding="utf-8"?>
+<file path=ppt/slides/slide36.xml><?xml version="1.0" encoding="utf-8"?>
 <p:sld xmlns:a="http://schemas.openxmlformats.org/drawingml/2006/main" xmlns:p="http://schemas.openxmlformats.org/presentationml/2006/main" xmlns:r="http://schemas.openxmlformats.org/officeDocument/2006/relationships">
   <p:cSld>
     <p:bg>
@@ -12089,7 +13705,7 @@
               </a:defRPr>
             </a:pPr>
             <a:r>
-              <a:t>11</a:t>
+              <a:t>12</a:t>
             </a:r>
           </a:p>
         </p:txBody>
@@ -12137,7 +13753,7 @@
 </p:sld>
 </file>
 
-<file path=ppt/slides/slide33.xml><?xml version="1.0" encoding="utf-8"?>
+<file path=ppt/slides/slide37.xml><?xml version="1.0" encoding="utf-8"?>
 <p:sld xmlns:a="http://schemas.openxmlformats.org/drawingml/2006/main" xmlns:p="http://schemas.openxmlformats.org/presentationml/2006/main" xmlns:r="http://schemas.openxmlformats.org/officeDocument/2006/relationships">
   <p:cSld>
     <p:bg>
@@ -12185,7 +13801,7 @@
               </a:defRPr>
             </a:pPr>
             <a:r>
-              <a:t>11. 完整移除</a:t>
+              <a:t>12. 完整移除</a:t>
             </a:r>
           </a:p>
         </p:txBody>
@@ -13182,7 +14798,7 @@
 </p:sld>
 </file>
 
-<file path=ppt/slides/slide34.xml><?xml version="1.0" encoding="utf-8"?>
+<file path=ppt/slides/slide38.xml><?xml version="1.0" encoding="utf-8"?>
 <p:sld xmlns:a="http://schemas.openxmlformats.org/drawingml/2006/main" xmlns:p="http://schemas.openxmlformats.org/presentationml/2006/main" xmlns:r="http://schemas.openxmlformats.org/officeDocument/2006/relationships">
   <p:cSld>
     <p:bg>

</xml_diff>

<commit_message>
[docs] regenerate PPT with updated install commands (pip install -e .)
Co-Authored-By: Claude Opus 4.6 <noreply@anthropic.com>
</commit_message>
<xml_diff>
--- a/docs/SOP-cross-platform.pptx
+++ b/docs/SOP-cross-platform.pptx
@@ -6705,7 +6705,7 @@
               </a:defRPr>
             </a:pPr>
             <a:r>
-              <a:t>$ pip install .</a:t>
+              <a:t>$ pip install -e .</a:t>
             </a:r>
           </a:p>
           <a:p>
@@ -17697,7 +17697,7 @@
               </a:defRPr>
             </a:pPr>
             <a:r>
-              <a:t>$ pip install .</a:t>
+              <a:t>$ pip install -e .</a:t>
             </a:r>
           </a:p>
           <a:p>
@@ -18040,7 +18040,7 @@
               </a:defRPr>
             </a:pPr>
             <a:r>
-              <a:t>$ pip install .</a:t>
+              <a:t>$ pip install -e .</a:t>
             </a:r>
           </a:p>
           <a:p>
@@ -18314,7 +18314,7 @@
               </a:defRPr>
             </a:pPr>
             <a:r>
-              <a:t>$ pip install .</a:t>
+              <a:t>$ pip install -e .</a:t>
             </a:r>
           </a:p>
           <a:p>

</xml_diff>